<commit_message>
Lighten Chapter 3 review deck colors and add playful transitions
Co-Authored-By: Claude Opus 5.5 <noreply@anthropic.com>
Claude-Session: https://claude.ai/code/session_018YigfV33yaj7JcWpm4EGQJ
</commit_message>
<xml_diff>
--- a/مراجعة-الفصل-الثالث-السلسلة-الغذائية.pptx
+++ b/مراجعة-الفصل-الثالث-السلسلة-الغذائية.pptx
@@ -122,17 +122,17 @@
   <p:extLst>
     <p:ext uri="{521415D9-36F7-43E2-AB2F-B90AF26B5E84}">
       <p14:sectionLst xmlns:p14="http://schemas.microsoft.com/office/powerpoint/2010/main">
-        <p14:section name="ترحيب" id="{5e9d6dca-b95f-2f1a-fffa-c6803788e83c}">
+        <p14:section name="ترحيب" id="{bcecb0c6-f0dc-3ee9-914c-1e4b3eb5edf7}">
           <p14:sldIdLst>
             <p14:sldId id="256"/>
           </p14:sldIdLst>
         </p14:section>
-        <p14:section name="لنتذكّر" id="{264b2b3e-39d0-e931-9231-5ca4a9b9f9ca}">
+        <p14:section name="لنتذكّر" id="{b8a00e8f-8aa9-fdbe-765c-40cf8f3f26b8}">
           <p14:sldIdLst>
             <p14:sldId id="257"/>
           </p14:sldIdLst>
         </p14:section>
-        <p14:section name="المفردات (ص 90)" id="{773e4d3d-f0e5-f624-0708-1d869233b7f1}">
+        <p14:section name="المفردات (ص 90)" id="{14d81866-26ba-75d5-f858-716fa5ff29bb}">
           <p14:sldIdLst>
             <p14:sldId id="258"/>
             <p14:sldId id="259"/>
@@ -140,7 +140,7 @@
             <p14:sldId id="261"/>
           </p14:sldIdLst>
         </p14:section>
-        <p14:section name="المهارات والأفكار العلمية (ص 91)" id="{b9960e0d-11b0-4d43-951f-f7f1528ef9e5}">
+        <p14:section name="المهارات والأفكار العلمية (ص 91)" id="{f0fcd550-0bed-5272-5ccd-8c2f3ae9a9c1}">
           <p14:sldIdLst>
             <p14:sldId id="262"/>
             <p14:sldId id="263"/>
@@ -150,13 +150,13 @@
             <p14:sldId id="267"/>
           </p14:sldIdLst>
         </p14:section>
-        <p14:section name="نموذج اختبار (ص 93)" id="{108fa01b-ac45-d278-dfb2-cc4ea314ef17}">
+        <p14:section name="نموذج اختبار (ص 93)" id="{79985770-e1db-a469-75a0-f1f8490ece88}">
           <p14:sldIdLst>
             <p14:sldId id="268"/>
             <p14:sldId id="269"/>
           </p14:sldIdLst>
         </p14:section>
-        <p14:section name="الدرس الجديد (ص 95)" id="{597b0747-397e-0064-e00a-dce4fed7eb84}">
+        <p14:section name="الدرس الجديد (ص 95)" id="{57f219e7-0273-3db2-3f4a-c32fdf1da099}">
           <p14:sldIdLst>
             <p14:sldId id="270"/>
             <p14:sldId id="271"/>
@@ -1964,7 +1964,7 @@
     <p:bg>
       <p:bgPr>
         <a:solidFill>
-          <a:schemeClr val="tx2"/>
+          <a:schemeClr val="bg1"/>
         </a:solidFill>
       </p:bgPr>
     </p:bg>
@@ -2449,36 +2449,268 @@
       </p:grpSpPr>
       <p:sp>
         <p:nvSpPr>
-          <p:cNvPr id="2" name="halo"/>
+          <p:cNvPr id="2" name="dot0"/>
           <p:cNvSpPr/>
           <p:nvPr/>
         </p:nvSpPr>
         <p:spPr>
           <a:xfrm>
-            <a:off x="411480" y="685800"/>
-            <a:ext cx="3291840" cy="3291840"/>
+            <a:off x="8229600" y="4663440"/>
+            <a:ext cx="365760" cy="365760"/>
+          </a:xfrm>
+          <a:prstGeom prst="ellipse">
+            <a:avLst/>
+          </a:prstGeom>
+          <a:solidFill>
+            <a:schemeClr val="accent5">
+              <a:alpha val="55000"/>
+            </a:schemeClr>
+          </a:solidFill>
+          <a:ln w="12700">
+            <a:solidFill>
+              <a:schemeClr val="accent5">
+                <a:alpha val="55000"/>
+              </a:schemeClr>
+            </a:solidFill>
+            <a:prstDash val="solid"/>
+          </a:ln>
+        </p:spPr>
+      </p:sp>
+      <p:sp>
+        <p:nvSpPr>
+          <p:cNvPr id="3" name="dot1"/>
+          <p:cNvSpPr/>
+          <p:nvPr/>
+        </p:nvSpPr>
+        <p:spPr>
+          <a:xfrm>
+            <a:off x="3886200" y="2103120"/>
+            <a:ext cx="274320" cy="274320"/>
+          </a:xfrm>
+          <a:prstGeom prst="ellipse">
+            <a:avLst/>
+          </a:prstGeom>
+          <a:solidFill>
+            <a:schemeClr val="accent2">
+              <a:alpha val="55000"/>
+            </a:schemeClr>
+          </a:solidFill>
+          <a:ln w="12700">
+            <a:solidFill>
+              <a:schemeClr val="accent2">
+                <a:alpha val="55000"/>
+              </a:schemeClr>
+            </a:solidFill>
+            <a:prstDash val="solid"/>
+          </a:ln>
+        </p:spPr>
+      </p:sp>
+      <p:sp>
+        <p:nvSpPr>
+          <p:cNvPr id="4" name="dot2"/>
+          <p:cNvSpPr/>
+          <p:nvPr/>
+        </p:nvSpPr>
+        <p:spPr>
+          <a:xfrm>
+            <a:off x="3840480" y="4480560"/>
+            <a:ext cx="411480" cy="411480"/>
           </a:xfrm>
           <a:prstGeom prst="ellipse">
             <a:avLst/>
           </a:prstGeom>
           <a:solidFill>
             <a:schemeClr val="accent1">
-              <a:alpha val="65000"/>
+              <a:alpha val="55000"/>
             </a:schemeClr>
           </a:solidFill>
           <a:ln w="12700">
             <a:solidFill>
               <a:schemeClr val="accent1">
-                <a:alpha val="65000"/>
+                <a:alpha val="55000"/>
               </a:schemeClr>
             </a:solidFill>
             <a:prstDash val="solid"/>
           </a:ln>
         </p:spPr>
       </p:sp>
+      <p:sp>
+        <p:nvSpPr>
+          <p:cNvPr id="5" name="dot3"/>
+          <p:cNvSpPr/>
+          <p:nvPr/>
+        </p:nvSpPr>
+        <p:spPr>
+          <a:xfrm>
+            <a:off x="3383280" y="228600"/>
+            <a:ext cx="365760" cy="365760"/>
+          </a:xfrm>
+          <a:prstGeom prst="ellipse">
+            <a:avLst/>
+          </a:prstGeom>
+          <a:solidFill>
+            <a:schemeClr val="accent4">
+              <a:alpha val="55000"/>
+            </a:schemeClr>
+          </a:solidFill>
+          <a:ln w="12700">
+            <a:solidFill>
+              <a:schemeClr val="accent4">
+                <a:alpha val="55000"/>
+              </a:schemeClr>
+            </a:solidFill>
+            <a:prstDash val="solid"/>
+          </a:ln>
+        </p:spPr>
+      </p:sp>
+      <p:sp>
+        <p:nvSpPr>
+          <p:cNvPr id="6" name="dot4"/>
+          <p:cNvSpPr/>
+          <p:nvPr/>
+        </p:nvSpPr>
+        <p:spPr>
+          <a:xfrm>
+            <a:off x="182880" y="4526280"/>
+            <a:ext cx="457200" cy="457200"/>
+          </a:xfrm>
+          <a:prstGeom prst="ellipse">
+            <a:avLst/>
+          </a:prstGeom>
+          <a:solidFill>
+            <a:schemeClr val="accent5">
+              <a:alpha val="55000"/>
+            </a:schemeClr>
+          </a:solidFill>
+          <a:ln w="12700">
+            <a:solidFill>
+              <a:schemeClr val="accent5">
+                <a:alpha val="55000"/>
+              </a:schemeClr>
+            </a:solidFill>
+            <a:prstDash val="solid"/>
+          </a:ln>
+        </p:spPr>
+      </p:sp>
+      <p:sp>
+        <p:nvSpPr>
+          <p:cNvPr id="7" name="dot5"/>
+          <p:cNvSpPr/>
+          <p:nvPr/>
+        </p:nvSpPr>
+        <p:spPr>
+          <a:xfrm>
+            <a:off x="8549640" y="182880"/>
+            <a:ext cx="274320" cy="274320"/>
+          </a:xfrm>
+          <a:prstGeom prst="ellipse">
+            <a:avLst/>
+          </a:prstGeom>
+          <a:solidFill>
+            <a:schemeClr val="accent1">
+              <a:alpha val="55000"/>
+            </a:schemeClr>
+          </a:solidFill>
+          <a:ln w="12700">
+            <a:solidFill>
+              <a:schemeClr val="accent1">
+                <a:alpha val="55000"/>
+              </a:schemeClr>
+            </a:solidFill>
+            <a:prstDash val="solid"/>
+          </a:ln>
+        </p:spPr>
+      </p:sp>
+      <p:sp>
+        <p:nvSpPr>
+          <p:cNvPr id="8" name="dot6"/>
+          <p:cNvSpPr/>
+          <p:nvPr/>
+        </p:nvSpPr>
+        <p:spPr>
+          <a:xfrm>
+            <a:off x="6035040" y="4617720"/>
+            <a:ext cx="274320" cy="274320"/>
+          </a:xfrm>
+          <a:prstGeom prst="ellipse">
+            <a:avLst/>
+          </a:prstGeom>
+          <a:solidFill>
+            <a:schemeClr val="accent4">
+              <a:alpha val="55000"/>
+            </a:schemeClr>
+          </a:solidFill>
+          <a:ln w="12700">
+            <a:solidFill>
+              <a:schemeClr val="accent4">
+                <a:alpha val="55000"/>
+              </a:schemeClr>
+            </a:solidFill>
+            <a:prstDash val="solid"/>
+          </a:ln>
+        </p:spPr>
+      </p:sp>
+      <p:sp>
+        <p:nvSpPr>
+          <p:cNvPr id="9" name="dot7"/>
+          <p:cNvSpPr/>
+          <p:nvPr/>
+        </p:nvSpPr>
+        <p:spPr>
+          <a:xfrm>
+            <a:off x="274320" y="274320"/>
+            <a:ext cx="320040" cy="320040"/>
+          </a:xfrm>
+          <a:prstGeom prst="ellipse">
+            <a:avLst/>
+          </a:prstGeom>
+          <a:solidFill>
+            <a:schemeClr val="accent2">
+              <a:alpha val="55000"/>
+            </a:schemeClr>
+          </a:solidFill>
+          <a:ln w="12700">
+            <a:solidFill>
+              <a:schemeClr val="accent2">
+                <a:alpha val="55000"/>
+              </a:schemeClr>
+            </a:solidFill>
+            <a:prstDash val="solid"/>
+          </a:ln>
+        </p:spPr>
+      </p:sp>
+      <p:sp>
+        <p:nvSpPr>
+          <p:cNvPr id="10" name="halo"/>
+          <p:cNvSpPr/>
+          <p:nvPr/>
+        </p:nvSpPr>
+        <p:spPr>
+          <a:xfrm>
+            <a:off x="411480" y="685800"/>
+            <a:ext cx="3291840" cy="3291840"/>
+          </a:xfrm>
+          <a:prstGeom prst="ellipse">
+            <a:avLst/>
+          </a:prstGeom>
+          <a:solidFill>
+            <a:schemeClr val="accent3">
+              <a:alpha val="80000"/>
+            </a:schemeClr>
+          </a:solidFill>
+          <a:ln w="12700">
+            <a:solidFill>
+              <a:schemeClr val="accent3">
+                <a:alpha val="80000"/>
+              </a:schemeClr>
+            </a:solidFill>
+            <a:prstDash val="solid"/>
+          </a:ln>
+        </p:spPr>
+      </p:sp>
       <p:pic>
         <p:nvPicPr>
-          <p:cNvPr id="3" name="girl" descr="طالبة تلوّح بيدها مرحّبة">    </p:cNvPr>
+          <p:cNvPr id="11" name="girl" descr="طالبة تلوّح بيدها مرحّبة">    </p:cNvPr>
           <p:cNvPicPr>
             <a:picLocks noChangeAspect="1"/>
           </p:cNvPicPr>
@@ -2502,7 +2734,7 @@
       </p:pic>
       <p:sp>
         <p:nvSpPr>
-          <p:cNvPr id="4" name="bubble"/>
+          <p:cNvPr id="12" name="bubble"/>
           <p:cNvSpPr txBox="1"/>
           <p:nvPr/>
         </p:nvSpPr>
@@ -2517,9 +2749,9 @@
           <a:solidFill>
             <a:schemeClr val="bg1"/>
           </a:solidFill>
-          <a:ln>
+          <a:ln w="31750">
             <a:solidFill>
-              <a:schemeClr val="bg1"/>
+              <a:schemeClr val="accent5"/>
             </a:solidFill>
           </a:ln>
         </p:spPr>
@@ -2558,7 +2790,7 @@
       </p:sp>
       <p:sp>
         <p:nvSpPr>
-          <p:cNvPr id="5" name="word0"/>
+          <p:cNvPr id="13" name="word0"/>
           <p:cNvSpPr txBox="1"/>
           <p:nvPr/>
         </p:nvSpPr>
@@ -2598,7 +2830,7 @@
       </p:sp>
       <p:sp>
         <p:nvSpPr>
-          <p:cNvPr id="6" name="word1"/>
+          <p:cNvPr id="14" name="word1"/>
           <p:cNvSpPr txBox="1"/>
           <p:nvPr/>
         </p:nvSpPr>
@@ -2638,7 +2870,7 @@
       </p:sp>
       <p:sp>
         <p:nvSpPr>
-          <p:cNvPr id="7" name="word2"/>
+          <p:cNvPr id="15" name="word2"/>
           <p:cNvSpPr txBox="1"/>
           <p:nvPr/>
         </p:nvSpPr>
@@ -2678,7 +2910,7 @@
       </p:sp>
       <p:sp>
         <p:nvSpPr>
-          <p:cNvPr id="8" name="sub"/>
+          <p:cNvPr id="16" name="sub"/>
           <p:cNvSpPr txBox="1"/>
           <p:nvPr/>
         </p:nvSpPr>
@@ -2703,7 +2935,7 @@
             <a:r>
               <a:rPr lang="en-US" sz="1400" dirty="0">
                 <a:solidFill>
-                  <a:schemeClr val="bg2"/>
+                  <a:schemeClr val="tx2"/>
                 </a:solidFill>
               </a:rPr>
               <a:t>مراجعة الفصل الثالث  |  العلوم – الصف الثاني</a:t>
@@ -2717,6 +2949,18 @@
   <p:clrMapOvr>
     <a:masterClrMapping/>
   </p:clrMapOvr>
+  <mc:AlternateContent xmlns:mc="http://schemas.openxmlformats.org/markup-compatibility/2006">
+    <mc:Choice xmlns:p14="http://schemas.microsoft.com/office/powerpoint/2010/main" Requires="p14">
+      <p:transition spd="slow" p14:dur="1400">
+        <p14:ripple/>
+      </p:transition>
+    </mc:Choice>
+    <mc:Fallback>
+      <p:transition spd="slow">
+        <p:fade/>
+      </p:transition>
+    </mc:Fallback>
+  </mc:AlternateContent>
 </p:sld>
 </file>
 
@@ -3025,9 +3269,13 @@
             </a:avLst>
           </a:prstGeom>
           <a:solidFill>
-            <a:schemeClr val="accent1"/>
+            <a:schemeClr val="accent6"/>
           </a:solidFill>
-          <a:ln/>
+          <a:ln w="19050">
+            <a:solidFill>
+              <a:schemeClr val="accent1"/>
+            </a:solidFill>
+          </a:ln>
           <a:effectLst>
             <a:outerShdw sx="100000" sy="100000" kx="0" ky="0" algn="bl" rotWithShape="0" blurRad="76200" dist="25400" dir="5400000">
               <a:srgbClr val="000000">
@@ -3049,7 +3297,7 @@
             <a:r>
               <a:rPr lang="en-US" sz="1900" b="1" dirty="0">
                 <a:solidFill>
-                  <a:schemeClr val="accent3"/>
+                  <a:schemeClr val="accent2"/>
                 </a:solidFill>
               </a:rPr>
               <a:t>أجزاء خاصة تحفظ الماء:</a:t>
@@ -3067,7 +3315,7 @@
             <a:r>
               <a:rPr lang="en-US" sz="1900" dirty="0">
                 <a:solidFill>
-                  <a:schemeClr val="bg1"/>
+                  <a:schemeClr val="tx1"/>
                 </a:solidFill>
               </a:rPr>
               <a:t>سيقان سميكة تخزّن الماء.</a:t>
@@ -3085,7 +3333,7 @@
             <a:r>
               <a:rPr lang="en-US" sz="1900" dirty="0">
                 <a:solidFill>
-                  <a:schemeClr val="bg1"/>
+                  <a:schemeClr val="tx1"/>
                 </a:solidFill>
               </a:rPr>
               <a:t>أوراق صغيرة أو أشواك تُقلّل فقدان الماء.</a:t>
@@ -3103,7 +3351,7 @@
             <a:r>
               <a:rPr lang="en-US" sz="1900" dirty="0">
                 <a:solidFill>
-                  <a:schemeClr val="bg1"/>
+                  <a:schemeClr val="tx1"/>
                 </a:solidFill>
               </a:rPr>
               <a:t>جذور طويلة أو منتشرة تجمع الماء.</a:t>
@@ -3162,6 +3410,18 @@
   <p:clrMapOvr>
     <a:masterClrMapping/>
   </p:clrMapOvr>
+  <mc:AlternateContent xmlns:mc="http://schemas.openxmlformats.org/markup-compatibility/2006">
+    <mc:Choice xmlns:p14="http://schemas.microsoft.com/office/powerpoint/2010/main" Requires="p14">
+      <p:transition spd="slow" p14:dur="1400">
+        <p14:prism/>
+      </p:transition>
+    </mc:Choice>
+    <mc:Fallback>
+      <p:transition spd="slow">
+        <p:push dir="u"/>
+      </p:transition>
+    </mc:Fallback>
+  </mc:AlternateContent>
   <p:timing>
     <p:tnLst>
       <p:par>
@@ -3183,7 +3443,7 @@
                             </p:stCondLst>
                             <p:childTnLst>
                               <p:par>
-                                <p:cTn id="5" presetID="10" presetClass="entr" presetSubtype="0" fill="hold" nodeType="clickEffect">
+                                <p:cTn id="5" presetID="53" presetClass="entr" presetSubtype="16" fill="hold" nodeType="clickEffect">
                                   <p:stCondLst>
                                     <p:cond delay="0"/>
                                   </p:stCondLst>
@@ -3206,9 +3466,65 @@
                                         <p:strVal val="visible"/>
                                       </p:to>
                                     </p:set>
+                                    <p:anim calcmode="lin" valueType="num">
+                                      <p:cBhvr>
+                                        <p:cTn id="7" dur="600" fill="hold"/>
+                                        <p:tgtEl>
+                                          <p:spTgt spid="10"/>
+                                        </p:tgtEl>
+                                        <p:attrNameLst>
+                                          <p:attrName>ppt_w</p:attrName>
+                                        </p:attrNameLst>
+                                      </p:cBhvr>
+                                      <p:tavLst>
+                                        <p:tav tm="0">
+                                          <p:val>
+                                            <p:fltVal val="0"/>
+                                          </p:val>
+                                        </p:tav>
+                                        <p:tav tm="65000">
+                                          <p:val>
+                                            <p:strVal val="#ppt_w*1.15"/>
+                                          </p:val>
+                                        </p:tav>
+                                        <p:tav tm="100000">
+                                          <p:val>
+                                            <p:strVal val="#ppt_w"/>
+                                          </p:val>
+                                        </p:tav>
+                                      </p:tavLst>
+                                    </p:anim>
+                                    <p:anim calcmode="lin" valueType="num">
+                                      <p:cBhvr>
+                                        <p:cTn id="8" dur="600" fill="hold"/>
+                                        <p:tgtEl>
+                                          <p:spTgt spid="10"/>
+                                        </p:tgtEl>
+                                        <p:attrNameLst>
+                                          <p:attrName>ppt_h</p:attrName>
+                                        </p:attrNameLst>
+                                      </p:cBhvr>
+                                      <p:tavLst>
+                                        <p:tav tm="0">
+                                          <p:val>
+                                            <p:fltVal val="0"/>
+                                          </p:val>
+                                        </p:tav>
+                                        <p:tav tm="65000">
+                                          <p:val>
+                                            <p:strVal val="#ppt_h*1.15"/>
+                                          </p:val>
+                                        </p:tav>
+                                        <p:tav tm="100000">
+                                          <p:val>
+                                            <p:strVal val="#ppt_h"/>
+                                          </p:val>
+                                        </p:tav>
+                                      </p:tavLst>
+                                    </p:anim>
                                     <p:animEffect transition="in" filter="fade">
                                       <p:cBhvr>
-                                        <p:cTn id="7" dur="500"/>
+                                        <p:cTn id="9" dur="400"/>
                                         <p:tgtEl>
                                           <p:spTgt spid="10"/>
                                         </p:tgtEl>
@@ -3597,9 +3913,13 @@
             </a:avLst>
           </a:prstGeom>
           <a:solidFill>
-            <a:schemeClr val="accent1"/>
+            <a:schemeClr val="accent6"/>
           </a:solidFill>
-          <a:ln/>
+          <a:ln w="19050">
+            <a:solidFill>
+              <a:schemeClr val="accent1"/>
+            </a:solidFill>
+          </a:ln>
           <a:effectLst>
             <a:outerShdw sx="100000" sy="100000" kx="0" ky="0" algn="bl" rotWithShape="0" blurRad="76200" dist="25400" dir="5400000">
               <a:srgbClr val="000000">
@@ -3618,7 +3938,7 @@
             <a:r>
               <a:rPr lang="en-US" sz="1700" b="1" dirty="0">
                 <a:solidFill>
-                  <a:schemeClr val="accent3"/>
+                  <a:schemeClr val="accent2"/>
                 </a:solidFill>
               </a:rPr>
               <a:t>الأولى: </a:t>
@@ -3629,7 +3949,7 @@
             <a:r>
               <a:rPr lang="en-US" sz="1700" dirty="0">
                 <a:solidFill>
-                  <a:schemeClr val="bg1"/>
+                  <a:schemeClr val="tx1"/>
                 </a:solidFill>
               </a:rPr>
               <a:t>نبات حيّ نضر، أزهاره صفراء.  </a:t>
@@ -3640,7 +3960,7 @@
             <a:r>
               <a:rPr lang="en-US" sz="1700" b="1" dirty="0">
                 <a:solidFill>
-                  <a:schemeClr val="accent3"/>
+                  <a:schemeClr val="accent2"/>
                 </a:solidFill>
               </a:rPr>
               <a:t>الثانية: </a:t>
@@ -3651,7 +3971,7 @@
             <a:r>
               <a:rPr lang="en-US" sz="1700" dirty="0">
                 <a:solidFill>
-                  <a:schemeClr val="bg1"/>
+                  <a:schemeClr val="tx1"/>
                 </a:solidFill>
               </a:rPr>
               <a:t>نبات ذابل جافّ، لونه بُنّي.</a:t>
@@ -3665,7 +3985,7 @@
             <a:r>
               <a:rPr lang="en-US" sz="1700" b="1" dirty="0">
                 <a:solidFill>
-                  <a:schemeClr val="accent3"/>
+                  <a:schemeClr val="accent2"/>
                 </a:solidFill>
               </a:rPr>
               <a:t>ما حدث: </a:t>
@@ -3676,7 +3996,7 @@
             <a:r>
               <a:rPr lang="en-US" sz="1700" dirty="0">
                 <a:solidFill>
-                  <a:schemeClr val="bg1"/>
+                  <a:schemeClr val="tx1"/>
                 </a:solidFill>
               </a:rPr>
               <a:t>لم يحصل النبات على حاجاته من الماء فذبل وجفّ.</a:t>
@@ -3735,6 +4055,18 @@
   <p:clrMapOvr>
     <a:masterClrMapping/>
   </p:clrMapOvr>
+  <mc:AlternateContent xmlns:mc="http://schemas.openxmlformats.org/markup-compatibility/2006">
+    <mc:Choice xmlns:p14="http://schemas.microsoft.com/office/powerpoint/2010/main" Requires="p14">
+      <p:transition spd="slow" p14:dur="1400">
+        <p14:ferris dir="l"/>
+      </p:transition>
+    </mc:Choice>
+    <mc:Fallback>
+      <p:transition spd="slow">
+        <p:push dir="r"/>
+      </p:transition>
+    </mc:Fallback>
+  </mc:AlternateContent>
   <p:timing>
     <p:tnLst>
       <p:par>
@@ -3756,7 +4088,7 @@
                             </p:stCondLst>
                             <p:childTnLst>
                               <p:par>
-                                <p:cTn id="5" presetID="10" presetClass="entr" presetSubtype="0" fill="hold" nodeType="clickEffect">
+                                <p:cTn id="5" presetID="53" presetClass="entr" presetSubtype="16" fill="hold" nodeType="clickEffect">
                                   <p:stCondLst>
                                     <p:cond delay="0"/>
                                   </p:stCondLst>
@@ -3779,9 +4111,65 @@
                                         <p:strVal val="visible"/>
                                       </p:to>
                                     </p:set>
+                                    <p:anim calcmode="lin" valueType="num">
+                                      <p:cBhvr>
+                                        <p:cTn id="7" dur="600" fill="hold"/>
+                                        <p:tgtEl>
+                                          <p:spTgt spid="11"/>
+                                        </p:tgtEl>
+                                        <p:attrNameLst>
+                                          <p:attrName>ppt_w</p:attrName>
+                                        </p:attrNameLst>
+                                      </p:cBhvr>
+                                      <p:tavLst>
+                                        <p:tav tm="0">
+                                          <p:val>
+                                            <p:fltVal val="0"/>
+                                          </p:val>
+                                        </p:tav>
+                                        <p:tav tm="65000">
+                                          <p:val>
+                                            <p:strVal val="#ppt_w*1.15"/>
+                                          </p:val>
+                                        </p:tav>
+                                        <p:tav tm="100000">
+                                          <p:val>
+                                            <p:strVal val="#ppt_w"/>
+                                          </p:val>
+                                        </p:tav>
+                                      </p:tavLst>
+                                    </p:anim>
+                                    <p:anim calcmode="lin" valueType="num">
+                                      <p:cBhvr>
+                                        <p:cTn id="8" dur="600" fill="hold"/>
+                                        <p:tgtEl>
+                                          <p:spTgt spid="11"/>
+                                        </p:tgtEl>
+                                        <p:attrNameLst>
+                                          <p:attrName>ppt_h</p:attrName>
+                                        </p:attrNameLst>
+                                      </p:cBhvr>
+                                      <p:tavLst>
+                                        <p:tav tm="0">
+                                          <p:val>
+                                            <p:fltVal val="0"/>
+                                          </p:val>
+                                        </p:tav>
+                                        <p:tav tm="65000">
+                                          <p:val>
+                                            <p:strVal val="#ppt_h*1.15"/>
+                                          </p:val>
+                                        </p:tav>
+                                        <p:tav tm="100000">
+                                          <p:val>
+                                            <p:strVal val="#ppt_h"/>
+                                          </p:val>
+                                        </p:tav>
+                                      </p:tavLst>
+                                    </p:anim>
                                     <p:animEffect transition="in" filter="fade">
                                       <p:cBhvr>
-                                        <p:cTn id="7" dur="500"/>
+                                        <p:cTn id="9" dur="400"/>
                                         <p:tgtEl>
                                           <p:spTgt spid="11"/>
                                         </p:tgtEl>
@@ -4090,9 +4478,13 @@
             </a:avLst>
           </a:prstGeom>
           <a:solidFill>
-            <a:schemeClr val="accent1"/>
+            <a:schemeClr val="accent6"/>
           </a:solidFill>
-          <a:ln/>
+          <a:ln w="19050">
+            <a:solidFill>
+              <a:schemeClr val="accent1"/>
+            </a:solidFill>
+          </a:ln>
           <a:effectLst>
             <a:outerShdw sx="100000" sy="100000" kx="0" ky="0" algn="bl" rotWithShape="0" blurRad="76200" dist="25400" dir="5400000">
               <a:srgbClr val="000000">
@@ -4111,7 +4503,7 @@
             <a:r>
               <a:rPr lang="en-US" sz="2200" b="1" dirty="0">
                 <a:solidFill>
-                  <a:schemeClr val="accent3"/>
+                  <a:schemeClr val="accent2"/>
                 </a:solidFill>
               </a:rPr>
               <a:t>الموطن: </a:t>
@@ -4122,7 +4514,7 @@
             <a:r>
               <a:rPr lang="en-US" sz="2200" dirty="0">
                 <a:solidFill>
-                  <a:schemeClr val="bg1"/>
+                  <a:schemeClr val="tx1"/>
                 </a:solidFill>
               </a:rPr>
               <a:t>هو المكان الذي يعيش فيه المخلوق الحيّ، ويحصل منه على حاجاته من غذاء وماء ومأوى.</a:t>
@@ -4181,6 +4573,18 @@
   <p:clrMapOvr>
     <a:masterClrMapping/>
   </p:clrMapOvr>
+  <mc:AlternateContent xmlns:mc="http://schemas.openxmlformats.org/markup-compatibility/2006">
+    <mc:Choice xmlns:p14="http://schemas.microsoft.com/office/powerpoint/2010/main" xmlns:p15="http://schemas.microsoft.com/office/powerpoint/2012/main" Requires="p15">
+      <p:transition spd="slow" p14:dur="1400">
+        <p15:prstTrans prst="airplane"/>
+      </p:transition>
+    </mc:Choice>
+    <mc:Fallback>
+      <p:transition spd="slow">
+        <p:fade/>
+      </p:transition>
+    </mc:Fallback>
+  </mc:AlternateContent>
   <p:timing>
     <p:tnLst>
       <p:par>
@@ -4202,7 +4606,7 @@
                             </p:stCondLst>
                             <p:childTnLst>
                               <p:par>
-                                <p:cTn id="5" presetID="10" presetClass="entr" presetSubtype="0" fill="hold" nodeType="clickEffect">
+                                <p:cTn id="5" presetID="53" presetClass="entr" presetSubtype="16" fill="hold" nodeType="clickEffect">
                                   <p:stCondLst>
                                     <p:cond delay="0"/>
                                   </p:stCondLst>
@@ -4225,9 +4629,65 @@
                                         <p:strVal val="visible"/>
                                       </p:to>
                                     </p:set>
+                                    <p:anim calcmode="lin" valueType="num">
+                                      <p:cBhvr>
+                                        <p:cTn id="7" dur="600" fill="hold"/>
+                                        <p:tgtEl>
+                                          <p:spTgt spid="9"/>
+                                        </p:tgtEl>
+                                        <p:attrNameLst>
+                                          <p:attrName>ppt_w</p:attrName>
+                                        </p:attrNameLst>
+                                      </p:cBhvr>
+                                      <p:tavLst>
+                                        <p:tav tm="0">
+                                          <p:val>
+                                            <p:fltVal val="0"/>
+                                          </p:val>
+                                        </p:tav>
+                                        <p:tav tm="65000">
+                                          <p:val>
+                                            <p:strVal val="#ppt_w*1.15"/>
+                                          </p:val>
+                                        </p:tav>
+                                        <p:tav tm="100000">
+                                          <p:val>
+                                            <p:strVal val="#ppt_w"/>
+                                          </p:val>
+                                        </p:tav>
+                                      </p:tavLst>
+                                    </p:anim>
+                                    <p:anim calcmode="lin" valueType="num">
+                                      <p:cBhvr>
+                                        <p:cTn id="8" dur="600" fill="hold"/>
+                                        <p:tgtEl>
+                                          <p:spTgt spid="9"/>
+                                        </p:tgtEl>
+                                        <p:attrNameLst>
+                                          <p:attrName>ppt_h</p:attrName>
+                                        </p:attrNameLst>
+                                      </p:cBhvr>
+                                      <p:tavLst>
+                                        <p:tav tm="0">
+                                          <p:val>
+                                            <p:fltVal val="0"/>
+                                          </p:val>
+                                        </p:tav>
+                                        <p:tav tm="65000">
+                                          <p:val>
+                                            <p:strVal val="#ppt_h*1.15"/>
+                                          </p:val>
+                                        </p:tav>
+                                        <p:tav tm="100000">
+                                          <p:val>
+                                            <p:strVal val="#ppt_h"/>
+                                          </p:val>
+                                        </p:tav>
+                                      </p:tavLst>
+                                    </p:anim>
                                     <p:animEffect transition="in" filter="fade">
                                       <p:cBhvr>
-                                        <p:cTn id="7" dur="500"/>
+                                        <p:cTn id="9" dur="400"/>
                                         <p:tgtEl>
                                           <p:spTgt spid="9"/>
                                         </p:tgtEl>
@@ -4696,9 +5156,13 @@
             </a:avLst>
           </a:prstGeom>
           <a:solidFill>
-            <a:schemeClr val="accent1"/>
+            <a:schemeClr val="accent6"/>
           </a:solidFill>
-          <a:ln/>
+          <a:ln w="19050">
+            <a:solidFill>
+              <a:schemeClr val="accent1"/>
+            </a:solidFill>
+          </a:ln>
           <a:effectLst>
             <a:outerShdw sx="100000" sy="100000" kx="0" ky="0" algn="bl" rotWithShape="0" blurRad="76200" dist="25400" dir="5400000">
               <a:srgbClr val="000000">
@@ -4717,7 +5181,7 @@
             <a:r>
               <a:rPr lang="en-US" sz="2000" b="1" dirty="0">
                 <a:solidFill>
-                  <a:schemeClr val="accent3"/>
+                  <a:schemeClr val="accent2"/>
                 </a:solidFill>
               </a:rPr>
               <a:t>الإجابة: </a:t>
@@ -4728,7 +5192,7 @@
             <a:r>
               <a:rPr lang="en-US" sz="2000" b="1" dirty="0">
                 <a:solidFill>
-                  <a:schemeClr val="bg1"/>
+                  <a:schemeClr val="tx1"/>
                 </a:solidFill>
               </a:rPr>
               <a:t>ب. عشبيٌّ ورطب</a:t>
@@ -4787,6 +5251,18 @@
   <p:clrMapOvr>
     <a:masterClrMapping/>
   </p:clrMapOvr>
+  <mc:AlternateContent xmlns:mc="http://schemas.openxmlformats.org/markup-compatibility/2006">
+    <mc:Choice xmlns:p14="http://schemas.microsoft.com/office/powerpoint/2010/main" Requires="p14">
+      <p:transition spd="slow" p14:dur="1400">
+        <p14:glitter dir="l" pattern="hexagon"/>
+      </p:transition>
+    </mc:Choice>
+    <mc:Fallback>
+      <p:transition spd="slow">
+        <p:dissolve/>
+      </p:transition>
+    </mc:Fallback>
+  </mc:AlternateContent>
   <p:timing>
     <p:tnLst>
       <p:par>
@@ -4808,7 +5284,7 @@
                             </p:stCondLst>
                             <p:childTnLst>
                               <p:par>
-                                <p:cTn id="5" presetID="10" presetClass="entr" presetSubtype="0" fill="hold" nodeType="clickEffect">
+                                <p:cTn id="5" presetID="53" presetClass="entr" presetSubtype="16" fill="hold" nodeType="clickEffect">
                                   <p:stCondLst>
                                     <p:cond delay="0"/>
                                   </p:stCondLst>
@@ -4831,9 +5307,65 @@
                                         <p:strVal val="visible"/>
                                       </p:to>
                                     </p:set>
+                                    <p:anim calcmode="lin" valueType="num">
+                                      <p:cBhvr>
+                                        <p:cTn id="7" dur="600" fill="hold"/>
+                                        <p:tgtEl>
+                                          <p:spTgt spid="13"/>
+                                        </p:tgtEl>
+                                        <p:attrNameLst>
+                                          <p:attrName>ppt_w</p:attrName>
+                                        </p:attrNameLst>
+                                      </p:cBhvr>
+                                      <p:tavLst>
+                                        <p:tav tm="0">
+                                          <p:val>
+                                            <p:fltVal val="0"/>
+                                          </p:val>
+                                        </p:tav>
+                                        <p:tav tm="65000">
+                                          <p:val>
+                                            <p:strVal val="#ppt_w*1.15"/>
+                                          </p:val>
+                                        </p:tav>
+                                        <p:tav tm="100000">
+                                          <p:val>
+                                            <p:strVal val="#ppt_w"/>
+                                          </p:val>
+                                        </p:tav>
+                                      </p:tavLst>
+                                    </p:anim>
+                                    <p:anim calcmode="lin" valueType="num">
+                                      <p:cBhvr>
+                                        <p:cTn id="8" dur="600" fill="hold"/>
+                                        <p:tgtEl>
+                                          <p:spTgt spid="13"/>
+                                        </p:tgtEl>
+                                        <p:attrNameLst>
+                                          <p:attrName>ppt_h</p:attrName>
+                                        </p:attrNameLst>
+                                      </p:cBhvr>
+                                      <p:tavLst>
+                                        <p:tav tm="0">
+                                          <p:val>
+                                            <p:fltVal val="0"/>
+                                          </p:val>
+                                        </p:tav>
+                                        <p:tav tm="65000">
+                                          <p:val>
+                                            <p:strVal val="#ppt_h*1.15"/>
+                                          </p:val>
+                                        </p:tav>
+                                        <p:tav tm="100000">
+                                          <p:val>
+                                            <p:strVal val="#ppt_h"/>
+                                          </p:val>
+                                        </p:tav>
+                                      </p:tavLst>
+                                    </p:anim>
                                     <p:animEffect transition="in" filter="fade">
                                       <p:cBhvr>
-                                        <p:cTn id="7" dur="500"/>
+                                        <p:cTn id="9" dur="400"/>
                                         <p:tgtEl>
                                           <p:spTgt spid="13"/>
                                         </p:tgtEl>
@@ -5302,9 +5834,13 @@
             </a:avLst>
           </a:prstGeom>
           <a:solidFill>
-            <a:schemeClr val="accent1"/>
+            <a:schemeClr val="accent6"/>
           </a:solidFill>
-          <a:ln/>
+          <a:ln w="19050">
+            <a:solidFill>
+              <a:schemeClr val="accent1"/>
+            </a:solidFill>
+          </a:ln>
           <a:effectLst>
             <a:outerShdw sx="100000" sy="100000" kx="0" ky="0" algn="bl" rotWithShape="0" blurRad="76200" dist="25400" dir="5400000">
               <a:srgbClr val="000000">
@@ -5323,7 +5859,7 @@
             <a:r>
               <a:rPr lang="en-US" sz="2000" b="1" dirty="0">
                 <a:solidFill>
-                  <a:schemeClr val="accent3"/>
+                  <a:schemeClr val="accent2"/>
                 </a:solidFill>
               </a:rPr>
               <a:t>الإجابة: </a:t>
@@ -5334,7 +5870,7 @@
             <a:r>
               <a:rPr lang="en-US" sz="2000" b="1" dirty="0">
                 <a:solidFill>
-                  <a:schemeClr val="bg1"/>
+                  <a:schemeClr val="tx1"/>
                 </a:solidFill>
               </a:rPr>
               <a:t>ج. الفأر</a:t>
@@ -5360,9 +5896,13 @@
             </a:avLst>
           </a:prstGeom>
           <a:solidFill>
-            <a:schemeClr val="accent1"/>
+            <a:schemeClr val="accent6"/>
           </a:solidFill>
-          <a:ln/>
+          <a:ln w="19050">
+            <a:solidFill>
+              <a:schemeClr val="accent1"/>
+            </a:solidFill>
+          </a:ln>
           <a:effectLst>
             <a:outerShdw sx="100000" sy="100000" kx="0" ky="0" algn="bl" rotWithShape="0" blurRad="76200" dist="25400" dir="5400000">
               <a:srgbClr val="000000">
@@ -5381,7 +5921,7 @@
             <a:r>
               <a:rPr lang="en-US" sz="1400" dirty="0">
                 <a:solidFill>
-                  <a:schemeClr val="bg1"/>
+                  <a:schemeClr val="tx1"/>
                 </a:solidFill>
               </a:rPr>
               <a:t>الأفعى تأكل الفأر، والصقر يأكل الأفعى.</a:t>
@@ -5440,6 +5980,18 @@
   <p:clrMapOvr>
     <a:masterClrMapping/>
   </p:clrMapOvr>
+  <mc:AlternateContent xmlns:mc="http://schemas.openxmlformats.org/markup-compatibility/2006">
+    <mc:Choice xmlns:p14="http://schemas.microsoft.com/office/powerpoint/2010/main" xmlns:p15="http://schemas.microsoft.com/office/powerpoint/2012/main" Requires="p15">
+      <p:transition spd="slow" p14:dur="1400">
+        <p15:prstTrans prst="fallOver"/>
+      </p:transition>
+    </mc:Choice>
+    <mc:Fallback>
+      <p:transition spd="slow">
+        <p:push dir="d"/>
+      </p:transition>
+    </mc:Fallback>
+  </mc:AlternateContent>
   <p:timing>
     <p:tnLst>
       <p:par>
@@ -5461,7 +6013,7 @@
                             </p:stCondLst>
                             <p:childTnLst>
                               <p:par>
-                                <p:cTn id="5" presetID="10" presetClass="entr" presetSubtype="0" fill="hold" nodeType="clickEffect">
+                                <p:cTn id="5" presetID="53" presetClass="entr" presetSubtype="16" fill="hold" nodeType="clickEffect">
                                   <p:stCondLst>
                                     <p:cond delay="0"/>
                                   </p:stCondLst>
@@ -5484,9 +6036,65 @@
                                         <p:strVal val="visible"/>
                                       </p:to>
                                     </p:set>
+                                    <p:anim calcmode="lin" valueType="num">
+                                      <p:cBhvr>
+                                        <p:cTn id="7" dur="600" fill="hold"/>
+                                        <p:tgtEl>
+                                          <p:spTgt spid="13"/>
+                                        </p:tgtEl>
+                                        <p:attrNameLst>
+                                          <p:attrName>ppt_w</p:attrName>
+                                        </p:attrNameLst>
+                                      </p:cBhvr>
+                                      <p:tavLst>
+                                        <p:tav tm="0">
+                                          <p:val>
+                                            <p:fltVal val="0"/>
+                                          </p:val>
+                                        </p:tav>
+                                        <p:tav tm="65000">
+                                          <p:val>
+                                            <p:strVal val="#ppt_w*1.15"/>
+                                          </p:val>
+                                        </p:tav>
+                                        <p:tav tm="100000">
+                                          <p:val>
+                                            <p:strVal val="#ppt_w"/>
+                                          </p:val>
+                                        </p:tav>
+                                      </p:tavLst>
+                                    </p:anim>
+                                    <p:anim calcmode="lin" valueType="num">
+                                      <p:cBhvr>
+                                        <p:cTn id="8" dur="600" fill="hold"/>
+                                        <p:tgtEl>
+                                          <p:spTgt spid="13"/>
+                                        </p:tgtEl>
+                                        <p:attrNameLst>
+                                          <p:attrName>ppt_h</p:attrName>
+                                        </p:attrNameLst>
+                                      </p:cBhvr>
+                                      <p:tavLst>
+                                        <p:tav tm="0">
+                                          <p:val>
+                                            <p:fltVal val="0"/>
+                                          </p:val>
+                                        </p:tav>
+                                        <p:tav tm="65000">
+                                          <p:val>
+                                            <p:strVal val="#ppt_h*1.15"/>
+                                          </p:val>
+                                        </p:tav>
+                                        <p:tav tm="100000">
+                                          <p:val>
+                                            <p:strVal val="#ppt_h"/>
+                                          </p:val>
+                                        </p:tav>
+                                      </p:tavLst>
+                                    </p:anim>
                                     <p:animEffect transition="in" filter="fade">
                                       <p:cBhvr>
-                                        <p:cTn id="7" dur="500"/>
+                                        <p:cTn id="9" dur="400"/>
                                         <p:tgtEl>
                                           <p:spTgt spid="13"/>
                                         </p:tgtEl>
@@ -5496,14 +6104,14 @@
                                 </p:cTn>
                               </p:par>
                               <p:par>
-                                <p:cTn id="8" presetID="10" presetClass="entr" presetSubtype="0" fill="hold" nodeType="withEffect">
+                                <p:cTn id="10" presetID="53" presetClass="entr" presetSubtype="16" fill="hold" nodeType="withEffect">
                                   <p:stCondLst>
                                     <p:cond delay="0"/>
                                   </p:stCondLst>
                                   <p:childTnLst>
                                     <p:set>
                                       <p:cBhvr>
-                                        <p:cTn id="9" dur="1" fill="hold">
+                                        <p:cTn id="11" dur="1" fill="hold">
                                           <p:stCondLst>
                                             <p:cond delay="0"/>
                                           </p:stCondLst>
@@ -5519,9 +6127,65 @@
                                         <p:strVal val="visible"/>
                                       </p:to>
                                     </p:set>
+                                    <p:anim calcmode="lin" valueType="num">
+                                      <p:cBhvr>
+                                        <p:cTn id="12" dur="600" fill="hold"/>
+                                        <p:tgtEl>
+                                          <p:spTgt spid="14"/>
+                                        </p:tgtEl>
+                                        <p:attrNameLst>
+                                          <p:attrName>ppt_w</p:attrName>
+                                        </p:attrNameLst>
+                                      </p:cBhvr>
+                                      <p:tavLst>
+                                        <p:tav tm="0">
+                                          <p:val>
+                                            <p:fltVal val="0"/>
+                                          </p:val>
+                                        </p:tav>
+                                        <p:tav tm="65000">
+                                          <p:val>
+                                            <p:strVal val="#ppt_w*1.15"/>
+                                          </p:val>
+                                        </p:tav>
+                                        <p:tav tm="100000">
+                                          <p:val>
+                                            <p:strVal val="#ppt_w"/>
+                                          </p:val>
+                                        </p:tav>
+                                      </p:tavLst>
+                                    </p:anim>
+                                    <p:anim calcmode="lin" valueType="num">
+                                      <p:cBhvr>
+                                        <p:cTn id="13" dur="600" fill="hold"/>
+                                        <p:tgtEl>
+                                          <p:spTgt spid="14"/>
+                                        </p:tgtEl>
+                                        <p:attrNameLst>
+                                          <p:attrName>ppt_h</p:attrName>
+                                        </p:attrNameLst>
+                                      </p:cBhvr>
+                                      <p:tavLst>
+                                        <p:tav tm="0">
+                                          <p:val>
+                                            <p:fltVal val="0"/>
+                                          </p:val>
+                                        </p:tav>
+                                        <p:tav tm="65000">
+                                          <p:val>
+                                            <p:strVal val="#ppt_h*1.15"/>
+                                          </p:val>
+                                        </p:tav>
+                                        <p:tav tm="100000">
+                                          <p:val>
+                                            <p:strVal val="#ppt_h"/>
+                                          </p:val>
+                                        </p:tav>
+                                      </p:tavLst>
+                                    </p:anim>
                                     <p:animEffect transition="in" filter="fade">
                                       <p:cBhvr>
-                                        <p:cTn id="10" dur="500"/>
+                                        <p:cTn id="14" dur="400"/>
                                         <p:tgtEl>
                                           <p:spTgt spid="14"/>
                                         </p:tgtEl>
@@ -5580,36 +6244,268 @@
       </p:grpSpPr>
       <p:sp>
         <p:nvSpPr>
-          <p:cNvPr id="2" name="halo"/>
+          <p:cNvPr id="2" name="dot0"/>
           <p:cNvSpPr/>
           <p:nvPr/>
         </p:nvSpPr>
         <p:spPr>
           <a:xfrm>
-            <a:off x="411480" y="685800"/>
-            <a:ext cx="3291840" cy="3291840"/>
+            <a:off x="8229600" y="4663440"/>
+            <a:ext cx="365760" cy="365760"/>
+          </a:xfrm>
+          <a:prstGeom prst="ellipse">
+            <a:avLst/>
+          </a:prstGeom>
+          <a:solidFill>
+            <a:schemeClr val="accent5">
+              <a:alpha val="55000"/>
+            </a:schemeClr>
+          </a:solidFill>
+          <a:ln w="12700">
+            <a:solidFill>
+              <a:schemeClr val="accent5">
+                <a:alpha val="55000"/>
+              </a:schemeClr>
+            </a:solidFill>
+            <a:prstDash val="solid"/>
+          </a:ln>
+        </p:spPr>
+      </p:sp>
+      <p:sp>
+        <p:nvSpPr>
+          <p:cNvPr id="3" name="dot1"/>
+          <p:cNvSpPr/>
+          <p:nvPr/>
+        </p:nvSpPr>
+        <p:spPr>
+          <a:xfrm>
+            <a:off x="3886200" y="2103120"/>
+            <a:ext cx="274320" cy="274320"/>
+          </a:xfrm>
+          <a:prstGeom prst="ellipse">
+            <a:avLst/>
+          </a:prstGeom>
+          <a:solidFill>
+            <a:schemeClr val="accent2">
+              <a:alpha val="55000"/>
+            </a:schemeClr>
+          </a:solidFill>
+          <a:ln w="12700">
+            <a:solidFill>
+              <a:schemeClr val="accent2">
+                <a:alpha val="55000"/>
+              </a:schemeClr>
+            </a:solidFill>
+            <a:prstDash val="solid"/>
+          </a:ln>
+        </p:spPr>
+      </p:sp>
+      <p:sp>
+        <p:nvSpPr>
+          <p:cNvPr id="4" name="dot2"/>
+          <p:cNvSpPr/>
+          <p:nvPr/>
+        </p:nvSpPr>
+        <p:spPr>
+          <a:xfrm>
+            <a:off x="3840480" y="4480560"/>
+            <a:ext cx="411480" cy="411480"/>
           </a:xfrm>
           <a:prstGeom prst="ellipse">
             <a:avLst/>
           </a:prstGeom>
           <a:solidFill>
             <a:schemeClr val="accent1">
-              <a:alpha val="65000"/>
+              <a:alpha val="55000"/>
             </a:schemeClr>
           </a:solidFill>
           <a:ln w="12700">
             <a:solidFill>
               <a:schemeClr val="accent1">
-                <a:alpha val="65000"/>
+                <a:alpha val="55000"/>
               </a:schemeClr>
             </a:solidFill>
             <a:prstDash val="solid"/>
           </a:ln>
         </p:spPr>
       </p:sp>
+      <p:sp>
+        <p:nvSpPr>
+          <p:cNvPr id="5" name="dot3"/>
+          <p:cNvSpPr/>
+          <p:nvPr/>
+        </p:nvSpPr>
+        <p:spPr>
+          <a:xfrm>
+            <a:off x="3383280" y="228600"/>
+            <a:ext cx="365760" cy="365760"/>
+          </a:xfrm>
+          <a:prstGeom prst="ellipse">
+            <a:avLst/>
+          </a:prstGeom>
+          <a:solidFill>
+            <a:schemeClr val="accent4">
+              <a:alpha val="55000"/>
+            </a:schemeClr>
+          </a:solidFill>
+          <a:ln w="12700">
+            <a:solidFill>
+              <a:schemeClr val="accent4">
+                <a:alpha val="55000"/>
+              </a:schemeClr>
+            </a:solidFill>
+            <a:prstDash val="solid"/>
+          </a:ln>
+        </p:spPr>
+      </p:sp>
+      <p:sp>
+        <p:nvSpPr>
+          <p:cNvPr id="6" name="dot4"/>
+          <p:cNvSpPr/>
+          <p:nvPr/>
+        </p:nvSpPr>
+        <p:spPr>
+          <a:xfrm>
+            <a:off x="182880" y="4526280"/>
+            <a:ext cx="457200" cy="457200"/>
+          </a:xfrm>
+          <a:prstGeom prst="ellipse">
+            <a:avLst/>
+          </a:prstGeom>
+          <a:solidFill>
+            <a:schemeClr val="accent5">
+              <a:alpha val="55000"/>
+            </a:schemeClr>
+          </a:solidFill>
+          <a:ln w="12700">
+            <a:solidFill>
+              <a:schemeClr val="accent5">
+                <a:alpha val="55000"/>
+              </a:schemeClr>
+            </a:solidFill>
+            <a:prstDash val="solid"/>
+          </a:ln>
+        </p:spPr>
+      </p:sp>
+      <p:sp>
+        <p:nvSpPr>
+          <p:cNvPr id="7" name="dot5"/>
+          <p:cNvSpPr/>
+          <p:nvPr/>
+        </p:nvSpPr>
+        <p:spPr>
+          <a:xfrm>
+            <a:off x="8549640" y="182880"/>
+            <a:ext cx="274320" cy="274320"/>
+          </a:xfrm>
+          <a:prstGeom prst="ellipse">
+            <a:avLst/>
+          </a:prstGeom>
+          <a:solidFill>
+            <a:schemeClr val="accent1">
+              <a:alpha val="55000"/>
+            </a:schemeClr>
+          </a:solidFill>
+          <a:ln w="12700">
+            <a:solidFill>
+              <a:schemeClr val="accent1">
+                <a:alpha val="55000"/>
+              </a:schemeClr>
+            </a:solidFill>
+            <a:prstDash val="solid"/>
+          </a:ln>
+        </p:spPr>
+      </p:sp>
+      <p:sp>
+        <p:nvSpPr>
+          <p:cNvPr id="8" name="dot6"/>
+          <p:cNvSpPr/>
+          <p:nvPr/>
+        </p:nvSpPr>
+        <p:spPr>
+          <a:xfrm>
+            <a:off x="6035040" y="4617720"/>
+            <a:ext cx="274320" cy="274320"/>
+          </a:xfrm>
+          <a:prstGeom prst="ellipse">
+            <a:avLst/>
+          </a:prstGeom>
+          <a:solidFill>
+            <a:schemeClr val="accent4">
+              <a:alpha val="55000"/>
+            </a:schemeClr>
+          </a:solidFill>
+          <a:ln w="12700">
+            <a:solidFill>
+              <a:schemeClr val="accent4">
+                <a:alpha val="55000"/>
+              </a:schemeClr>
+            </a:solidFill>
+            <a:prstDash val="solid"/>
+          </a:ln>
+        </p:spPr>
+      </p:sp>
+      <p:sp>
+        <p:nvSpPr>
+          <p:cNvPr id="9" name="dot7"/>
+          <p:cNvSpPr/>
+          <p:nvPr/>
+        </p:nvSpPr>
+        <p:spPr>
+          <a:xfrm>
+            <a:off x="274320" y="274320"/>
+            <a:ext cx="320040" cy="320040"/>
+          </a:xfrm>
+          <a:prstGeom prst="ellipse">
+            <a:avLst/>
+          </a:prstGeom>
+          <a:solidFill>
+            <a:schemeClr val="accent2">
+              <a:alpha val="55000"/>
+            </a:schemeClr>
+          </a:solidFill>
+          <a:ln w="12700">
+            <a:solidFill>
+              <a:schemeClr val="accent2">
+                <a:alpha val="55000"/>
+              </a:schemeClr>
+            </a:solidFill>
+            <a:prstDash val="solid"/>
+          </a:ln>
+        </p:spPr>
+      </p:sp>
+      <p:sp>
+        <p:nvSpPr>
+          <p:cNvPr id="10" name="halo"/>
+          <p:cNvSpPr/>
+          <p:nvPr/>
+        </p:nvSpPr>
+        <p:spPr>
+          <a:xfrm>
+            <a:off x="411480" y="685800"/>
+            <a:ext cx="3291840" cy="3291840"/>
+          </a:xfrm>
+          <a:prstGeom prst="ellipse">
+            <a:avLst/>
+          </a:prstGeom>
+          <a:solidFill>
+            <a:schemeClr val="accent3">
+              <a:alpha val="80000"/>
+            </a:schemeClr>
+          </a:solidFill>
+          <a:ln w="12700">
+            <a:solidFill>
+              <a:schemeClr val="accent3">
+                <a:alpha val="80000"/>
+              </a:schemeClr>
+            </a:solidFill>
+            <a:prstDash val="solid"/>
+          </a:ln>
+        </p:spPr>
+      </p:sp>
       <p:pic>
         <p:nvPicPr>
-          <p:cNvPr id="3" name="girl" descr="طالبة تلوّح بيدها">    </p:cNvPr>
+          <p:cNvPr id="11" name="girl" descr="طالبة تلوّح بيدها">    </p:cNvPr>
           <p:cNvPicPr>
             <a:picLocks noChangeAspect="1"/>
           </p:cNvPicPr>
@@ -5633,7 +6529,7 @@
       </p:pic>
       <p:sp>
         <p:nvSpPr>
-          <p:cNvPr id="4" name="bubble"/>
+          <p:cNvPr id="12" name="bubble"/>
           <p:cNvSpPr txBox="1"/>
           <p:nvPr/>
         </p:nvSpPr>
@@ -5648,9 +6544,9 @@
           <a:solidFill>
             <a:schemeClr val="bg1"/>
           </a:solidFill>
-          <a:ln>
+          <a:ln w="31750">
             <a:solidFill>
-              <a:schemeClr val="bg1"/>
+              <a:schemeClr val="accent5"/>
             </a:solidFill>
           </a:ln>
         </p:spPr>
@@ -5689,7 +6585,7 @@
       </p:sp>
       <p:sp>
         <p:nvSpPr>
-          <p:cNvPr id="5" name="ch"/>
+          <p:cNvPr id="13" name="ch"/>
           <p:cNvSpPr txBox="1"/>
           <p:nvPr/>
         </p:nvSpPr>
@@ -5714,7 +6610,7 @@
             <a:r>
               <a:rPr lang="en-US" sz="2200" b="1" dirty="0">
                 <a:solidFill>
-                  <a:schemeClr val="accent3"/>
+                  <a:schemeClr val="accent2"/>
                 </a:solidFill>
               </a:rPr>
               <a:t>الفصل الرابع</a:t>
@@ -5725,7 +6621,7 @@
       </p:sp>
       <p:sp>
         <p:nvSpPr>
-          <p:cNvPr id="6" name="chname"/>
+          <p:cNvPr id="14" name="chname"/>
           <p:cNvSpPr txBox="1"/>
           <p:nvPr/>
         </p:nvSpPr>
@@ -5750,7 +6646,7 @@
             <a:r>
               <a:rPr lang="en-US" sz="4400" b="1" dirty="0">
                 <a:solidFill>
-                  <a:schemeClr val="bg1"/>
+                  <a:schemeClr val="tx2"/>
                 </a:solidFill>
               </a:rPr>
               <a:t>أنواع المواطن</a:t>
@@ -5764,6 +6660,18 @@
   <p:clrMapOvr>
     <a:masterClrMapping/>
   </p:clrMapOvr>
+  <mc:AlternateContent xmlns:mc="http://schemas.openxmlformats.org/markup-compatibility/2006">
+    <mc:Choice xmlns:p14="http://schemas.microsoft.com/office/powerpoint/2010/main" xmlns:p15="http://schemas.microsoft.com/office/powerpoint/2012/main" Requires="p15">
+      <p:transition spd="slow" p14:dur="1400">
+        <p15:prstTrans prst="wind"/>
+      </p:transition>
+    </mc:Choice>
+    <mc:Fallback>
+      <p:transition spd="slow">
+        <p:cover dir="r"/>
+      </p:transition>
+    </mc:Fallback>
+  </mc:AlternateContent>
 </p:sld>
 </file>
 
@@ -6436,6 +7344,18 @@
   <p:clrMapOvr>
     <a:masterClrMapping/>
   </p:clrMapOvr>
+  <mc:AlternateContent xmlns:mc="http://schemas.openxmlformats.org/markup-compatibility/2006">
+    <mc:Choice xmlns:p14="http://schemas.microsoft.com/office/powerpoint/2010/main" Requires="p14">
+      <p:transition spd="slow" p14:dur="1400">
+        <p14:ripple/>
+      </p:transition>
+    </mc:Choice>
+    <mc:Fallback>
+      <p:transition spd="slow">
+        <p:zoom/>
+      </p:transition>
+    </mc:Fallback>
+  </mc:AlternateContent>
 </p:sld>
 </file>
 
@@ -7085,6 +8005,18 @@
   <p:clrMapOvr>
     <a:masterClrMapping/>
   </p:clrMapOvr>
+  <mc:AlternateContent xmlns:mc="http://schemas.openxmlformats.org/markup-compatibility/2006">
+    <mc:Choice xmlns:p14="http://schemas.microsoft.com/office/powerpoint/2010/main" xmlns:p15="http://schemas.microsoft.com/office/powerpoint/2012/main" Requires="p15">
+      <p:transition spd="slow" p14:dur="1400">
+        <p15:prstTrans prst="curtains"/>
+      </p:transition>
+    </mc:Choice>
+    <mc:Fallback>
+      <p:transition spd="slow">
+        <p:split orient="vert" dir="out"/>
+      </p:transition>
+    </mc:Fallback>
+  </mc:AlternateContent>
 </p:sld>
 </file>
 
@@ -7585,6 +8517,18 @@
   <p:clrMapOvr>
     <a:masterClrMapping/>
   </p:clrMapOvr>
+  <mc:AlternateContent xmlns:mc="http://schemas.openxmlformats.org/markup-compatibility/2006">
+    <mc:Choice xmlns:p14="http://schemas.microsoft.com/office/powerpoint/2010/main" Requires="p14">
+      <p:transition spd="slow" p14:dur="1400">
+        <p14:honeycomb/>
+      </p:transition>
+    </mc:Choice>
+    <mc:Fallback>
+      <p:transition spd="slow">
+        <p:circle/>
+      </p:transition>
+    </mc:Fallback>
+  </mc:AlternateContent>
 </p:sld>
 </file>
 
@@ -7832,9 +8776,13 @@
             </a:avLst>
           </a:prstGeom>
           <a:solidFill>
-            <a:schemeClr val="accent1"/>
+            <a:schemeClr val="accent6"/>
           </a:solidFill>
-          <a:ln/>
+          <a:ln w="19050">
+            <a:solidFill>
+              <a:schemeClr val="accent1"/>
+            </a:solidFill>
+          </a:ln>
           <a:effectLst>
             <a:outerShdw sx="100000" sy="100000" kx="0" ky="0" algn="bl" rotWithShape="0" blurRad="76200" dist="25400" dir="5400000">
               <a:srgbClr val="000000">
@@ -7853,7 +8801,7 @@
             <a:r>
               <a:rPr lang="en-US" sz="2200" b="1" dirty="0">
                 <a:solidFill>
-                  <a:schemeClr val="accent3"/>
+                  <a:schemeClr val="accent2"/>
                 </a:solidFill>
               </a:rPr>
               <a:t>الإجابة: </a:t>
@@ -7864,7 +8812,7 @@
             <a:r>
               <a:rPr lang="en-US" sz="2200" b="1" dirty="0">
                 <a:solidFill>
-                  <a:schemeClr val="bg1"/>
+                  <a:schemeClr val="tx1"/>
                 </a:solidFill>
               </a:rPr>
               <a:t>الموطن</a:t>
@@ -7890,9 +8838,13 @@
             </a:avLst>
           </a:prstGeom>
           <a:solidFill>
-            <a:schemeClr val="accent1"/>
+            <a:schemeClr val="accent6"/>
           </a:solidFill>
-          <a:ln/>
+          <a:ln w="19050">
+            <a:solidFill>
+              <a:schemeClr val="accent1"/>
+            </a:solidFill>
+          </a:ln>
           <a:effectLst>
             <a:outerShdw sx="100000" sy="100000" kx="0" ky="0" algn="bl" rotWithShape="0" blurRad="76200" dist="25400" dir="5400000">
               <a:srgbClr val="000000">
@@ -7911,7 +8863,7 @@
             <a:r>
               <a:rPr lang="en-US" sz="1600" dirty="0">
                 <a:solidFill>
-                  <a:schemeClr val="bg1"/>
+                  <a:schemeClr val="tx1"/>
                 </a:solidFill>
               </a:rPr>
               <a:t>الموطن هو المكان الذي يجد فيه المخلوق الحي غذاءه وماءه ومأواه.</a:t>
@@ -7970,6 +8922,18 @@
   <p:clrMapOvr>
     <a:masterClrMapping/>
   </p:clrMapOvr>
+  <mc:AlternateContent xmlns:mc="http://schemas.openxmlformats.org/markup-compatibility/2006">
+    <mc:Choice xmlns:p14="http://schemas.microsoft.com/office/powerpoint/2010/main" Requires="p14">
+      <p:transition spd="slow" p14:dur="1400">
+        <p14:switch dir="r"/>
+      </p:transition>
+    </mc:Choice>
+    <mc:Fallback>
+      <p:transition spd="slow">
+        <p:push dir="l"/>
+      </p:transition>
+    </mc:Fallback>
+  </mc:AlternateContent>
   <p:timing>
     <p:tnLst>
       <p:par>
@@ -7991,7 +8955,7 @@
                             </p:stCondLst>
                             <p:childTnLst>
                               <p:par>
-                                <p:cTn id="5" presetID="10" presetClass="entr" presetSubtype="0" fill="hold" nodeType="clickEffect">
+                                <p:cTn id="5" presetID="53" presetClass="entr" presetSubtype="16" fill="hold" nodeType="clickEffect">
                                   <p:stCondLst>
                                     <p:cond delay="0"/>
                                   </p:stCondLst>
@@ -8014,9 +8978,65 @@
                                         <p:strVal val="visible"/>
                                       </p:to>
                                     </p:set>
+                                    <p:anim calcmode="lin" valueType="num">
+                                      <p:cBhvr>
+                                        <p:cTn id="7" dur="600" fill="hold"/>
+                                        <p:tgtEl>
+                                          <p:spTgt spid="8"/>
+                                        </p:tgtEl>
+                                        <p:attrNameLst>
+                                          <p:attrName>ppt_w</p:attrName>
+                                        </p:attrNameLst>
+                                      </p:cBhvr>
+                                      <p:tavLst>
+                                        <p:tav tm="0">
+                                          <p:val>
+                                            <p:fltVal val="0"/>
+                                          </p:val>
+                                        </p:tav>
+                                        <p:tav tm="65000">
+                                          <p:val>
+                                            <p:strVal val="#ppt_w*1.15"/>
+                                          </p:val>
+                                        </p:tav>
+                                        <p:tav tm="100000">
+                                          <p:val>
+                                            <p:strVal val="#ppt_w"/>
+                                          </p:val>
+                                        </p:tav>
+                                      </p:tavLst>
+                                    </p:anim>
+                                    <p:anim calcmode="lin" valueType="num">
+                                      <p:cBhvr>
+                                        <p:cTn id="8" dur="600" fill="hold"/>
+                                        <p:tgtEl>
+                                          <p:spTgt spid="8"/>
+                                        </p:tgtEl>
+                                        <p:attrNameLst>
+                                          <p:attrName>ppt_h</p:attrName>
+                                        </p:attrNameLst>
+                                      </p:cBhvr>
+                                      <p:tavLst>
+                                        <p:tav tm="0">
+                                          <p:val>
+                                            <p:fltVal val="0"/>
+                                          </p:val>
+                                        </p:tav>
+                                        <p:tav tm="65000">
+                                          <p:val>
+                                            <p:strVal val="#ppt_h*1.15"/>
+                                          </p:val>
+                                        </p:tav>
+                                        <p:tav tm="100000">
+                                          <p:val>
+                                            <p:strVal val="#ppt_h"/>
+                                          </p:val>
+                                        </p:tav>
+                                      </p:tavLst>
+                                    </p:anim>
                                     <p:animEffect transition="in" filter="fade">
                                       <p:cBhvr>
-                                        <p:cTn id="7" dur="500"/>
+                                        <p:cTn id="9" dur="400"/>
                                         <p:tgtEl>
                                           <p:spTgt spid="8"/>
                                         </p:tgtEl>
@@ -8026,14 +9046,14 @@
                                 </p:cTn>
                               </p:par>
                               <p:par>
-                                <p:cTn id="8" presetID="10" presetClass="entr" presetSubtype="0" fill="hold" nodeType="withEffect">
+                                <p:cTn id="10" presetID="53" presetClass="entr" presetSubtype="16" fill="hold" nodeType="withEffect">
                                   <p:stCondLst>
                                     <p:cond delay="0"/>
                                   </p:stCondLst>
                                   <p:childTnLst>
                                     <p:set>
                                       <p:cBhvr>
-                                        <p:cTn id="9" dur="1" fill="hold">
+                                        <p:cTn id="11" dur="1" fill="hold">
                                           <p:stCondLst>
                                             <p:cond delay="0"/>
                                           </p:stCondLst>
@@ -8049,9 +9069,65 @@
                                         <p:strVal val="visible"/>
                                       </p:to>
                                     </p:set>
+                                    <p:anim calcmode="lin" valueType="num">
+                                      <p:cBhvr>
+                                        <p:cTn id="12" dur="600" fill="hold"/>
+                                        <p:tgtEl>
+                                          <p:spTgt spid="9"/>
+                                        </p:tgtEl>
+                                        <p:attrNameLst>
+                                          <p:attrName>ppt_w</p:attrName>
+                                        </p:attrNameLst>
+                                      </p:cBhvr>
+                                      <p:tavLst>
+                                        <p:tav tm="0">
+                                          <p:val>
+                                            <p:fltVal val="0"/>
+                                          </p:val>
+                                        </p:tav>
+                                        <p:tav tm="65000">
+                                          <p:val>
+                                            <p:strVal val="#ppt_w*1.15"/>
+                                          </p:val>
+                                        </p:tav>
+                                        <p:tav tm="100000">
+                                          <p:val>
+                                            <p:strVal val="#ppt_w"/>
+                                          </p:val>
+                                        </p:tav>
+                                      </p:tavLst>
+                                    </p:anim>
+                                    <p:anim calcmode="lin" valueType="num">
+                                      <p:cBhvr>
+                                        <p:cTn id="13" dur="600" fill="hold"/>
+                                        <p:tgtEl>
+                                          <p:spTgt spid="9"/>
+                                        </p:tgtEl>
+                                        <p:attrNameLst>
+                                          <p:attrName>ppt_h</p:attrName>
+                                        </p:attrNameLst>
+                                      </p:cBhvr>
+                                      <p:tavLst>
+                                        <p:tav tm="0">
+                                          <p:val>
+                                            <p:fltVal val="0"/>
+                                          </p:val>
+                                        </p:tav>
+                                        <p:tav tm="65000">
+                                          <p:val>
+                                            <p:strVal val="#ppt_h*1.15"/>
+                                          </p:val>
+                                        </p:tav>
+                                        <p:tav tm="100000">
+                                          <p:val>
+                                            <p:strVal val="#ppt_h"/>
+                                          </p:val>
+                                        </p:tav>
+                                      </p:tavLst>
+                                    </p:anim>
                                     <p:animEffect transition="in" filter="fade">
                                       <p:cBhvr>
-                                        <p:cTn id="10" dur="500"/>
+                                        <p:cTn id="14" dur="400"/>
                                         <p:tgtEl>
                                           <p:spTgt spid="9"/>
                                         </p:tgtEl>
@@ -8334,9 +9410,13 @@
             </a:avLst>
           </a:prstGeom>
           <a:solidFill>
-            <a:schemeClr val="accent1"/>
+            <a:schemeClr val="accent6"/>
           </a:solidFill>
-          <a:ln/>
+          <a:ln w="19050">
+            <a:solidFill>
+              <a:schemeClr val="accent1"/>
+            </a:solidFill>
+          </a:ln>
           <a:effectLst>
             <a:outerShdw sx="100000" sy="100000" kx="0" ky="0" algn="bl" rotWithShape="0" blurRad="76200" dist="25400" dir="5400000">
               <a:srgbClr val="000000">
@@ -8355,7 +9435,7 @@
             <a:r>
               <a:rPr lang="en-US" sz="2000" b="1" dirty="0">
                 <a:solidFill>
-                  <a:schemeClr val="accent3"/>
+                  <a:schemeClr val="accent2"/>
                 </a:solidFill>
               </a:rPr>
               <a:t>الإجابة: </a:t>
@@ -8366,7 +9446,7 @@
             <a:r>
               <a:rPr lang="en-US" sz="2000" b="1" dirty="0">
                 <a:solidFill>
-                  <a:schemeClr val="bg1"/>
+                  <a:schemeClr val="tx1"/>
                 </a:solidFill>
               </a:rPr>
               <a:t>سلسلة غذائية</a:t>
@@ -8392,9 +9472,13 @@
             </a:avLst>
           </a:prstGeom>
           <a:solidFill>
-            <a:schemeClr val="accent1"/>
+            <a:schemeClr val="accent6"/>
           </a:solidFill>
-          <a:ln/>
+          <a:ln w="19050">
+            <a:solidFill>
+              <a:schemeClr val="accent1"/>
+            </a:solidFill>
+          </a:ln>
           <a:effectLst>
             <a:outerShdw sx="100000" sy="100000" kx="0" ky="0" algn="bl" rotWithShape="0" blurRad="76200" dist="25400" dir="5400000">
               <a:srgbClr val="000000">
@@ -8413,7 +9497,7 @@
             <a:r>
               <a:rPr lang="en-US" sz="1600" dirty="0">
                 <a:solidFill>
-                  <a:schemeClr val="bg1"/>
+                  <a:schemeClr val="tx1"/>
                 </a:solidFill>
               </a:rPr>
               <a:t>نباتات وحيوانات صغيرة ← الروبيان ← فرس البحر</a:t>
@@ -8472,6 +9556,18 @@
   <p:clrMapOvr>
     <a:masterClrMapping/>
   </p:clrMapOvr>
+  <mc:AlternateContent xmlns:mc="http://schemas.openxmlformats.org/markup-compatibility/2006">
+    <mc:Choice xmlns:p14="http://schemas.microsoft.com/office/powerpoint/2010/main" Requires="p14">
+      <p:transition spd="slow" p14:dur="1400">
+        <p14:flip dir="l"/>
+      </p:transition>
+    </mc:Choice>
+    <mc:Fallback>
+      <p:transition spd="slow">
+        <p:wheel spokes="1"/>
+      </p:transition>
+    </mc:Fallback>
+  </mc:AlternateContent>
   <p:timing>
     <p:tnLst>
       <p:par>
@@ -8493,7 +9589,7 @@
                             </p:stCondLst>
                             <p:childTnLst>
                               <p:par>
-                                <p:cTn id="5" presetID="10" presetClass="entr" presetSubtype="0" fill="hold" nodeType="clickEffect">
+                                <p:cTn id="5" presetID="53" presetClass="entr" presetSubtype="16" fill="hold" nodeType="clickEffect">
                                   <p:stCondLst>
                                     <p:cond delay="0"/>
                                   </p:stCondLst>
@@ -8516,9 +9612,65 @@
                                         <p:strVal val="visible"/>
                                       </p:to>
                                     </p:set>
+                                    <p:anim calcmode="lin" valueType="num">
+                                      <p:cBhvr>
+                                        <p:cTn id="7" dur="600" fill="hold"/>
+                                        <p:tgtEl>
+                                          <p:spTgt spid="8"/>
+                                        </p:tgtEl>
+                                        <p:attrNameLst>
+                                          <p:attrName>ppt_w</p:attrName>
+                                        </p:attrNameLst>
+                                      </p:cBhvr>
+                                      <p:tavLst>
+                                        <p:tav tm="0">
+                                          <p:val>
+                                            <p:fltVal val="0"/>
+                                          </p:val>
+                                        </p:tav>
+                                        <p:tav tm="65000">
+                                          <p:val>
+                                            <p:strVal val="#ppt_w*1.15"/>
+                                          </p:val>
+                                        </p:tav>
+                                        <p:tav tm="100000">
+                                          <p:val>
+                                            <p:strVal val="#ppt_w"/>
+                                          </p:val>
+                                        </p:tav>
+                                      </p:tavLst>
+                                    </p:anim>
+                                    <p:anim calcmode="lin" valueType="num">
+                                      <p:cBhvr>
+                                        <p:cTn id="8" dur="600" fill="hold"/>
+                                        <p:tgtEl>
+                                          <p:spTgt spid="8"/>
+                                        </p:tgtEl>
+                                        <p:attrNameLst>
+                                          <p:attrName>ppt_h</p:attrName>
+                                        </p:attrNameLst>
+                                      </p:cBhvr>
+                                      <p:tavLst>
+                                        <p:tav tm="0">
+                                          <p:val>
+                                            <p:fltVal val="0"/>
+                                          </p:val>
+                                        </p:tav>
+                                        <p:tav tm="65000">
+                                          <p:val>
+                                            <p:strVal val="#ppt_h*1.15"/>
+                                          </p:val>
+                                        </p:tav>
+                                        <p:tav tm="100000">
+                                          <p:val>
+                                            <p:strVal val="#ppt_h"/>
+                                          </p:val>
+                                        </p:tav>
+                                      </p:tavLst>
+                                    </p:anim>
                                     <p:animEffect transition="in" filter="fade">
                                       <p:cBhvr>
-                                        <p:cTn id="7" dur="500"/>
+                                        <p:cTn id="9" dur="400"/>
                                         <p:tgtEl>
                                           <p:spTgt spid="8"/>
                                         </p:tgtEl>
@@ -8528,14 +9680,14 @@
                                 </p:cTn>
                               </p:par>
                               <p:par>
-                                <p:cTn id="8" presetID="10" presetClass="entr" presetSubtype="0" fill="hold" nodeType="withEffect">
+                                <p:cTn id="10" presetID="53" presetClass="entr" presetSubtype="16" fill="hold" nodeType="withEffect">
                                   <p:stCondLst>
                                     <p:cond delay="0"/>
                                   </p:stCondLst>
                                   <p:childTnLst>
                                     <p:set>
                                       <p:cBhvr>
-                                        <p:cTn id="9" dur="1" fill="hold">
+                                        <p:cTn id="11" dur="1" fill="hold">
                                           <p:stCondLst>
                                             <p:cond delay="0"/>
                                           </p:stCondLst>
@@ -8551,9 +9703,65 @@
                                         <p:strVal val="visible"/>
                                       </p:to>
                                     </p:set>
+                                    <p:anim calcmode="lin" valueType="num">
+                                      <p:cBhvr>
+                                        <p:cTn id="12" dur="600" fill="hold"/>
+                                        <p:tgtEl>
+                                          <p:spTgt spid="9"/>
+                                        </p:tgtEl>
+                                        <p:attrNameLst>
+                                          <p:attrName>ppt_w</p:attrName>
+                                        </p:attrNameLst>
+                                      </p:cBhvr>
+                                      <p:tavLst>
+                                        <p:tav tm="0">
+                                          <p:val>
+                                            <p:fltVal val="0"/>
+                                          </p:val>
+                                        </p:tav>
+                                        <p:tav tm="65000">
+                                          <p:val>
+                                            <p:strVal val="#ppt_w*1.15"/>
+                                          </p:val>
+                                        </p:tav>
+                                        <p:tav tm="100000">
+                                          <p:val>
+                                            <p:strVal val="#ppt_w"/>
+                                          </p:val>
+                                        </p:tav>
+                                      </p:tavLst>
+                                    </p:anim>
+                                    <p:anim calcmode="lin" valueType="num">
+                                      <p:cBhvr>
+                                        <p:cTn id="13" dur="600" fill="hold"/>
+                                        <p:tgtEl>
+                                          <p:spTgt spid="9"/>
+                                        </p:tgtEl>
+                                        <p:attrNameLst>
+                                          <p:attrName>ppt_h</p:attrName>
+                                        </p:attrNameLst>
+                                      </p:cBhvr>
+                                      <p:tavLst>
+                                        <p:tav tm="0">
+                                          <p:val>
+                                            <p:fltVal val="0"/>
+                                          </p:val>
+                                        </p:tav>
+                                        <p:tav tm="65000">
+                                          <p:val>
+                                            <p:strVal val="#ppt_h*1.15"/>
+                                          </p:val>
+                                        </p:tav>
+                                        <p:tav tm="100000">
+                                          <p:val>
+                                            <p:strVal val="#ppt_h"/>
+                                          </p:val>
+                                        </p:tav>
+                                      </p:tavLst>
+                                    </p:anim>
                                     <p:animEffect transition="in" filter="fade">
                                       <p:cBhvr>
-                                        <p:cTn id="10" dur="500"/>
+                                        <p:cTn id="14" dur="400"/>
                                         <p:tgtEl>
                                           <p:spTgt spid="9"/>
                                         </p:tgtEl>
@@ -8870,9 +10078,13 @@
             </a:avLst>
           </a:prstGeom>
           <a:solidFill>
-            <a:schemeClr val="accent1"/>
+            <a:schemeClr val="accent6"/>
           </a:solidFill>
-          <a:ln/>
+          <a:ln w="19050">
+            <a:solidFill>
+              <a:schemeClr val="accent1"/>
+            </a:solidFill>
+          </a:ln>
           <a:effectLst>
             <a:outerShdw sx="100000" sy="100000" kx="0" ky="0" algn="bl" rotWithShape="0" blurRad="76200" dist="25400" dir="5400000">
               <a:srgbClr val="000000">
@@ -8891,7 +10103,7 @@
             <a:r>
               <a:rPr lang="en-US" sz="2200" b="1" dirty="0">
                 <a:solidFill>
-                  <a:schemeClr val="accent3"/>
+                  <a:schemeClr val="accent2"/>
                 </a:solidFill>
               </a:rPr>
               <a:t>الإجابة: </a:t>
@@ -8902,7 +10114,7 @@
             <a:r>
               <a:rPr lang="en-US" sz="2200" b="1" dirty="0">
                 <a:solidFill>
-                  <a:schemeClr val="bg1"/>
+                  <a:schemeClr val="tx1"/>
                 </a:solidFill>
               </a:rPr>
               <a:t>الفريسة</a:t>
@@ -9036,9 +10248,13 @@
             </a:avLst>
           </a:prstGeom>
           <a:solidFill>
-            <a:schemeClr val="accent1"/>
+            <a:schemeClr val="accent6"/>
           </a:solidFill>
-          <a:ln/>
+          <a:ln w="19050">
+            <a:solidFill>
+              <a:schemeClr val="accent1"/>
+            </a:solidFill>
+          </a:ln>
           <a:effectLst>
             <a:outerShdw sx="100000" sy="100000" kx="0" ky="0" algn="bl" rotWithShape="0" blurRad="76200" dist="25400" dir="5400000">
               <a:srgbClr val="000000">
@@ -9057,7 +10273,7 @@
             <a:r>
               <a:rPr lang="en-US" sz="2200" b="1" dirty="0">
                 <a:solidFill>
-                  <a:schemeClr val="accent3"/>
+                  <a:schemeClr val="accent2"/>
                 </a:solidFill>
               </a:rPr>
               <a:t>الإجابة: </a:t>
@@ -9068,7 +10284,7 @@
             <a:r>
               <a:rPr lang="en-US" sz="2200" b="1" dirty="0">
                 <a:solidFill>
-                  <a:schemeClr val="bg1"/>
+                  <a:schemeClr val="tx1"/>
                 </a:solidFill>
               </a:rPr>
               <a:t>المفترس</a:t>
@@ -9127,6 +10343,18 @@
   <p:clrMapOvr>
     <a:masterClrMapping/>
   </p:clrMapOvr>
+  <mc:AlternateContent xmlns:mc="http://schemas.openxmlformats.org/markup-compatibility/2006">
+    <mc:Choice xmlns:p14="http://schemas.microsoft.com/office/powerpoint/2010/main" xmlns:p15="http://schemas.microsoft.com/office/powerpoint/2012/main" Requires="p15">
+      <p:transition spd="slow" p14:dur="1400">
+        <p15:prstTrans prst="origami"/>
+      </p:transition>
+    </mc:Choice>
+    <mc:Fallback>
+      <p:transition spd="slow">
+        <p:zoom/>
+      </p:transition>
+    </mc:Fallback>
+  </mc:AlternateContent>
   <p:timing>
     <p:tnLst>
       <p:par>
@@ -9148,7 +10376,7 @@
                             </p:stCondLst>
                             <p:childTnLst>
                               <p:par>
-                                <p:cTn id="5" presetID="10" presetClass="entr" presetSubtype="0" fill="hold" nodeType="clickEffect">
+                                <p:cTn id="5" presetID="53" presetClass="entr" presetSubtype="16" fill="hold" nodeType="clickEffect">
                                   <p:stCondLst>
                                     <p:cond delay="0"/>
                                   </p:stCondLst>
@@ -9171,9 +10399,65 @@
                                         <p:strVal val="visible"/>
                                       </p:to>
                                     </p:set>
+                                    <p:anim calcmode="lin" valueType="num">
+                                      <p:cBhvr>
+                                        <p:cTn id="7" dur="600" fill="hold"/>
+                                        <p:tgtEl>
+                                          <p:spTgt spid="9"/>
+                                        </p:tgtEl>
+                                        <p:attrNameLst>
+                                          <p:attrName>ppt_w</p:attrName>
+                                        </p:attrNameLst>
+                                      </p:cBhvr>
+                                      <p:tavLst>
+                                        <p:tav tm="0">
+                                          <p:val>
+                                            <p:fltVal val="0"/>
+                                          </p:val>
+                                        </p:tav>
+                                        <p:tav tm="65000">
+                                          <p:val>
+                                            <p:strVal val="#ppt_w*1.15"/>
+                                          </p:val>
+                                        </p:tav>
+                                        <p:tav tm="100000">
+                                          <p:val>
+                                            <p:strVal val="#ppt_w"/>
+                                          </p:val>
+                                        </p:tav>
+                                      </p:tavLst>
+                                    </p:anim>
+                                    <p:anim calcmode="lin" valueType="num">
+                                      <p:cBhvr>
+                                        <p:cTn id="8" dur="600" fill="hold"/>
+                                        <p:tgtEl>
+                                          <p:spTgt spid="9"/>
+                                        </p:tgtEl>
+                                        <p:attrNameLst>
+                                          <p:attrName>ppt_h</p:attrName>
+                                        </p:attrNameLst>
+                                      </p:cBhvr>
+                                      <p:tavLst>
+                                        <p:tav tm="0">
+                                          <p:val>
+                                            <p:fltVal val="0"/>
+                                          </p:val>
+                                        </p:tav>
+                                        <p:tav tm="65000">
+                                          <p:val>
+                                            <p:strVal val="#ppt_h*1.15"/>
+                                          </p:val>
+                                        </p:tav>
+                                        <p:tav tm="100000">
+                                          <p:val>
+                                            <p:strVal val="#ppt_h"/>
+                                          </p:val>
+                                        </p:tav>
+                                      </p:tavLst>
+                                    </p:anim>
                                     <p:animEffect transition="in" filter="fade">
                                       <p:cBhvr>
-                                        <p:cTn id="7" dur="500"/>
+                                        <p:cTn id="9" dur="400"/>
                                         <p:tgtEl>
                                           <p:spTgt spid="9"/>
                                         </p:tgtEl>
@@ -9189,26 +10473,26 @@
                     </p:cTn>
                   </p:par>
                   <p:par>
-                    <p:cTn id="8" fill="hold">
+                    <p:cTn id="10" fill="hold">
                       <p:stCondLst>
                         <p:cond delay="indefinite"/>
                       </p:stCondLst>
                       <p:childTnLst>
                         <p:par>
-                          <p:cTn id="9" fill="hold">
+                          <p:cTn id="11" fill="hold">
                             <p:stCondLst>
                               <p:cond delay="0"/>
                             </p:stCondLst>
                             <p:childTnLst>
                               <p:par>
-                                <p:cTn id="10" presetID="10" presetClass="entr" presetSubtype="0" fill="hold" nodeType="clickEffect">
+                                <p:cTn id="12" presetID="53" presetClass="entr" presetSubtype="16" fill="hold" nodeType="clickEffect">
                                   <p:stCondLst>
                                     <p:cond delay="0"/>
                                   </p:stCondLst>
                                   <p:childTnLst>
                                     <p:set>
                                       <p:cBhvr>
-                                        <p:cTn id="11" dur="1" fill="hold">
+                                        <p:cTn id="13" dur="1" fill="hold">
                                           <p:stCondLst>
                                             <p:cond delay="0"/>
                                           </p:stCondLst>
@@ -9224,9 +10508,65 @@
                                         <p:strVal val="visible"/>
                                       </p:to>
                                     </p:set>
+                                    <p:anim calcmode="lin" valueType="num">
+                                      <p:cBhvr>
+                                        <p:cTn id="14" dur="600" fill="hold"/>
+                                        <p:tgtEl>
+                                          <p:spTgt spid="13"/>
+                                        </p:tgtEl>
+                                        <p:attrNameLst>
+                                          <p:attrName>ppt_w</p:attrName>
+                                        </p:attrNameLst>
+                                      </p:cBhvr>
+                                      <p:tavLst>
+                                        <p:tav tm="0">
+                                          <p:val>
+                                            <p:fltVal val="0"/>
+                                          </p:val>
+                                        </p:tav>
+                                        <p:tav tm="65000">
+                                          <p:val>
+                                            <p:strVal val="#ppt_w*1.15"/>
+                                          </p:val>
+                                        </p:tav>
+                                        <p:tav tm="100000">
+                                          <p:val>
+                                            <p:strVal val="#ppt_w"/>
+                                          </p:val>
+                                        </p:tav>
+                                      </p:tavLst>
+                                    </p:anim>
+                                    <p:anim calcmode="lin" valueType="num">
+                                      <p:cBhvr>
+                                        <p:cTn id="15" dur="600" fill="hold"/>
+                                        <p:tgtEl>
+                                          <p:spTgt spid="13"/>
+                                        </p:tgtEl>
+                                        <p:attrNameLst>
+                                          <p:attrName>ppt_h</p:attrName>
+                                        </p:attrNameLst>
+                                      </p:cBhvr>
+                                      <p:tavLst>
+                                        <p:tav tm="0">
+                                          <p:val>
+                                            <p:fltVal val="0"/>
+                                          </p:val>
+                                        </p:tav>
+                                        <p:tav tm="65000">
+                                          <p:val>
+                                            <p:strVal val="#ppt_h*1.15"/>
+                                          </p:val>
+                                        </p:tav>
+                                        <p:tav tm="100000">
+                                          <p:val>
+                                            <p:strVal val="#ppt_h"/>
+                                          </p:val>
+                                        </p:tav>
+                                      </p:tavLst>
+                                    </p:anim>
                                     <p:animEffect transition="in" filter="fade">
                                       <p:cBhvr>
-                                        <p:cTn id="12" dur="500"/>
+                                        <p:cTn id="16" dur="400"/>
                                         <p:tgtEl>
                                           <p:spTgt spid="13"/>
                                         </p:tgtEl>
@@ -9285,32 +10625,264 @@
       </p:grpSpPr>
       <p:sp>
         <p:nvSpPr>
-          <p:cNvPr id="2" name="secbg"/>
+          <p:cNvPr id="2" name="dot0"/>
           <p:cNvSpPr/>
           <p:nvPr/>
         </p:nvSpPr>
         <p:spPr>
           <a:xfrm>
-            <a:off x="3749040" y="640080"/>
-            <a:ext cx="1645920" cy="1645920"/>
+            <a:off x="8229600" y="4663440"/>
+            <a:ext cx="365760" cy="365760"/>
           </a:xfrm>
           <a:prstGeom prst="ellipse">
             <a:avLst/>
           </a:prstGeom>
           <a:solidFill>
-            <a:schemeClr val="bg1"/>
+            <a:schemeClr val="accent5">
+              <a:alpha val="55000"/>
+            </a:schemeClr>
           </a:solidFill>
           <a:ln w="12700">
             <a:solidFill>
-              <a:schemeClr val="bg1"/>
+              <a:schemeClr val="accent5">
+                <a:alpha val="55000"/>
+              </a:schemeClr>
             </a:solidFill>
             <a:prstDash val="solid"/>
           </a:ln>
         </p:spPr>
       </p:sp>
+      <p:sp>
+        <p:nvSpPr>
+          <p:cNvPr id="3" name="dot1"/>
+          <p:cNvSpPr/>
+          <p:nvPr/>
+        </p:nvSpPr>
+        <p:spPr>
+          <a:xfrm>
+            <a:off x="3886200" y="2103120"/>
+            <a:ext cx="274320" cy="274320"/>
+          </a:xfrm>
+          <a:prstGeom prst="ellipse">
+            <a:avLst/>
+          </a:prstGeom>
+          <a:solidFill>
+            <a:schemeClr val="accent2">
+              <a:alpha val="55000"/>
+            </a:schemeClr>
+          </a:solidFill>
+          <a:ln w="12700">
+            <a:solidFill>
+              <a:schemeClr val="accent2">
+                <a:alpha val="55000"/>
+              </a:schemeClr>
+            </a:solidFill>
+            <a:prstDash val="solid"/>
+          </a:ln>
+        </p:spPr>
+      </p:sp>
+      <p:sp>
+        <p:nvSpPr>
+          <p:cNvPr id="4" name="dot2"/>
+          <p:cNvSpPr/>
+          <p:nvPr/>
+        </p:nvSpPr>
+        <p:spPr>
+          <a:xfrm>
+            <a:off x="3840480" y="4480560"/>
+            <a:ext cx="411480" cy="411480"/>
+          </a:xfrm>
+          <a:prstGeom prst="ellipse">
+            <a:avLst/>
+          </a:prstGeom>
+          <a:solidFill>
+            <a:schemeClr val="accent1">
+              <a:alpha val="55000"/>
+            </a:schemeClr>
+          </a:solidFill>
+          <a:ln w="12700">
+            <a:solidFill>
+              <a:schemeClr val="accent1">
+                <a:alpha val="55000"/>
+              </a:schemeClr>
+            </a:solidFill>
+            <a:prstDash val="solid"/>
+          </a:ln>
+        </p:spPr>
+      </p:sp>
+      <p:sp>
+        <p:nvSpPr>
+          <p:cNvPr id="5" name="dot3"/>
+          <p:cNvSpPr/>
+          <p:nvPr/>
+        </p:nvSpPr>
+        <p:spPr>
+          <a:xfrm>
+            <a:off x="3383280" y="228600"/>
+            <a:ext cx="365760" cy="365760"/>
+          </a:xfrm>
+          <a:prstGeom prst="ellipse">
+            <a:avLst/>
+          </a:prstGeom>
+          <a:solidFill>
+            <a:schemeClr val="accent4">
+              <a:alpha val="55000"/>
+            </a:schemeClr>
+          </a:solidFill>
+          <a:ln w="12700">
+            <a:solidFill>
+              <a:schemeClr val="accent4">
+                <a:alpha val="55000"/>
+              </a:schemeClr>
+            </a:solidFill>
+            <a:prstDash val="solid"/>
+          </a:ln>
+        </p:spPr>
+      </p:sp>
+      <p:sp>
+        <p:nvSpPr>
+          <p:cNvPr id="6" name="dot4"/>
+          <p:cNvSpPr/>
+          <p:nvPr/>
+        </p:nvSpPr>
+        <p:spPr>
+          <a:xfrm>
+            <a:off x="182880" y="4526280"/>
+            <a:ext cx="457200" cy="457200"/>
+          </a:xfrm>
+          <a:prstGeom prst="ellipse">
+            <a:avLst/>
+          </a:prstGeom>
+          <a:solidFill>
+            <a:schemeClr val="accent5">
+              <a:alpha val="55000"/>
+            </a:schemeClr>
+          </a:solidFill>
+          <a:ln w="12700">
+            <a:solidFill>
+              <a:schemeClr val="accent5">
+                <a:alpha val="55000"/>
+              </a:schemeClr>
+            </a:solidFill>
+            <a:prstDash val="solid"/>
+          </a:ln>
+        </p:spPr>
+      </p:sp>
+      <p:sp>
+        <p:nvSpPr>
+          <p:cNvPr id="7" name="dot5"/>
+          <p:cNvSpPr/>
+          <p:nvPr/>
+        </p:nvSpPr>
+        <p:spPr>
+          <a:xfrm>
+            <a:off x="8549640" y="182880"/>
+            <a:ext cx="274320" cy="274320"/>
+          </a:xfrm>
+          <a:prstGeom prst="ellipse">
+            <a:avLst/>
+          </a:prstGeom>
+          <a:solidFill>
+            <a:schemeClr val="accent1">
+              <a:alpha val="55000"/>
+            </a:schemeClr>
+          </a:solidFill>
+          <a:ln w="12700">
+            <a:solidFill>
+              <a:schemeClr val="accent1">
+                <a:alpha val="55000"/>
+              </a:schemeClr>
+            </a:solidFill>
+            <a:prstDash val="solid"/>
+          </a:ln>
+        </p:spPr>
+      </p:sp>
+      <p:sp>
+        <p:nvSpPr>
+          <p:cNvPr id="8" name="dot6"/>
+          <p:cNvSpPr/>
+          <p:nvPr/>
+        </p:nvSpPr>
+        <p:spPr>
+          <a:xfrm>
+            <a:off x="6035040" y="4617720"/>
+            <a:ext cx="274320" cy="274320"/>
+          </a:xfrm>
+          <a:prstGeom prst="ellipse">
+            <a:avLst/>
+          </a:prstGeom>
+          <a:solidFill>
+            <a:schemeClr val="accent4">
+              <a:alpha val="55000"/>
+            </a:schemeClr>
+          </a:solidFill>
+          <a:ln w="12700">
+            <a:solidFill>
+              <a:schemeClr val="accent4">
+                <a:alpha val="55000"/>
+              </a:schemeClr>
+            </a:solidFill>
+            <a:prstDash val="solid"/>
+          </a:ln>
+        </p:spPr>
+      </p:sp>
+      <p:sp>
+        <p:nvSpPr>
+          <p:cNvPr id="9" name="dot7"/>
+          <p:cNvSpPr/>
+          <p:nvPr/>
+        </p:nvSpPr>
+        <p:spPr>
+          <a:xfrm>
+            <a:off x="274320" y="274320"/>
+            <a:ext cx="320040" cy="320040"/>
+          </a:xfrm>
+          <a:prstGeom prst="ellipse">
+            <a:avLst/>
+          </a:prstGeom>
+          <a:solidFill>
+            <a:schemeClr val="accent2">
+              <a:alpha val="55000"/>
+            </a:schemeClr>
+          </a:solidFill>
+          <a:ln w="12700">
+            <a:solidFill>
+              <a:schemeClr val="accent2">
+                <a:alpha val="55000"/>
+              </a:schemeClr>
+            </a:solidFill>
+            <a:prstDash val="solid"/>
+          </a:ln>
+        </p:spPr>
+      </p:sp>
+      <p:sp>
+        <p:nvSpPr>
+          <p:cNvPr id="10" name="secbg"/>
+          <p:cNvSpPr/>
+          <p:nvPr/>
+        </p:nvSpPr>
+        <p:spPr>
+          <a:xfrm>
+            <a:off x="3749040" y="640080"/>
+            <a:ext cx="1645920" cy="1645920"/>
+          </a:xfrm>
+          <a:prstGeom prst="ellipse">
+            <a:avLst/>
+          </a:prstGeom>
+          <a:solidFill>
+            <a:schemeClr val="accent3"/>
+          </a:solidFill>
+          <a:ln w="12700">
+            <a:solidFill>
+              <a:schemeClr val="accent3"/>
+            </a:solidFill>
+            <a:prstDash val="solid"/>
+          </a:ln>
+        </p:spPr>
+      </p:sp>
       <p:pic>
         <p:nvPicPr>
-          <p:cNvPr id="3" name="secicon" descr="فكرة">    </p:cNvPr>
+          <p:cNvPr id="11" name="secicon" descr="فكرة">    </p:cNvPr>
           <p:cNvPicPr>
             <a:picLocks noChangeAspect="1"/>
           </p:cNvPicPr>
@@ -9334,7 +10906,7 @@
       </p:pic>
       <p:sp>
         <p:nvSpPr>
-          <p:cNvPr id="4" name="sectitle"/>
+          <p:cNvPr id="12" name="sectitle"/>
           <p:cNvSpPr txBox="1"/>
           <p:nvPr/>
         </p:nvSpPr>
@@ -9359,7 +10931,7 @@
             <a:r>
               <a:rPr lang="en-US" sz="4000" b="1" dirty="0">
                 <a:solidFill>
-                  <a:schemeClr val="bg1"/>
+                  <a:schemeClr val="tx2"/>
                 </a:solidFill>
               </a:rPr>
               <a:t>المهارات والأفكار العلمية</a:t>
@@ -9370,7 +10942,7 @@
       </p:sp>
       <p:sp>
         <p:nvSpPr>
-          <p:cNvPr id="5" name="secsub"/>
+          <p:cNvPr id="13" name="secsub"/>
           <p:cNvSpPr txBox="1"/>
           <p:nvPr/>
         </p:nvSpPr>
@@ -9395,7 +10967,7 @@
             <a:r>
               <a:rPr lang="en-US" sz="2200" dirty="0">
                 <a:solidFill>
-                  <a:schemeClr val="accent3"/>
+                  <a:schemeClr val="accent2"/>
                 </a:solidFill>
               </a:rPr>
               <a:t>أجيبي عن الأسئلة التالية</a:t>
@@ -9409,6 +10981,18 @@
   <p:clrMapOvr>
     <a:masterClrMapping/>
   </p:clrMapOvr>
+  <mc:AlternateContent xmlns:mc="http://schemas.openxmlformats.org/markup-compatibility/2006">
+    <mc:Choice xmlns:p14="http://schemas.microsoft.com/office/powerpoint/2010/main" Requires="p14">
+      <p:transition spd="slow" p14:dur="1400">
+        <p14:vortex dir="r"/>
+      </p:transition>
+    </mc:Choice>
+    <mc:Fallback>
+      <p:transition spd="slow">
+        <p:wheel spokes="4"/>
+      </p:transition>
+    </mc:Fallback>
+  </mc:AlternateContent>
 </p:sld>
 </file>
 
@@ -9643,9 +11227,13 @@
             </a:avLst>
           </a:prstGeom>
           <a:solidFill>
-            <a:schemeClr val="accent1"/>
+            <a:schemeClr val="accent6"/>
           </a:solidFill>
-          <a:ln/>
+          <a:ln w="19050">
+            <a:solidFill>
+              <a:schemeClr val="accent1"/>
+            </a:solidFill>
+          </a:ln>
           <a:effectLst>
             <a:outerShdw sx="100000" sy="100000" kx="0" ky="0" algn="bl" rotWithShape="0" blurRad="76200" dist="25400" dir="5400000">
               <a:srgbClr val="000000">
@@ -9667,7 +11255,7 @@
             <a:r>
               <a:rPr lang="en-US" sz="1800" b="1" dirty="0">
                 <a:solidFill>
-                  <a:schemeClr val="accent3"/>
+                  <a:schemeClr val="accent2"/>
                 </a:solidFill>
               </a:rPr>
               <a:t>الحيوانات تستفيد من النباتات</a:t>
@@ -9685,7 +11273,7 @@
             <a:r>
               <a:rPr lang="en-US" sz="1800" dirty="0">
                 <a:solidFill>
-                  <a:schemeClr val="bg1"/>
+                  <a:schemeClr val="tx1"/>
                 </a:solidFill>
               </a:rPr>
               <a:t>تأكلها غذاءً لها.</a:t>
@@ -9703,7 +11291,7 @@
             <a:r>
               <a:rPr lang="en-US" sz="1800" dirty="0">
                 <a:solidFill>
-                  <a:schemeClr val="bg1"/>
+                  <a:schemeClr val="tx1"/>
                 </a:solidFill>
               </a:rPr>
               <a:t>تعيش فيها وتحتمي بها (مأوى).</a:t>
@@ -9729,9 +11317,13 @@
             </a:avLst>
           </a:prstGeom>
           <a:solidFill>
-            <a:schemeClr val="accent1"/>
+            <a:schemeClr val="accent6"/>
           </a:solidFill>
-          <a:ln/>
+          <a:ln w="19050">
+            <a:solidFill>
+              <a:schemeClr val="accent1"/>
+            </a:solidFill>
+          </a:ln>
           <a:effectLst>
             <a:outerShdw sx="100000" sy="100000" kx="0" ky="0" algn="bl" rotWithShape="0" blurRad="76200" dist="25400" dir="5400000">
               <a:srgbClr val="000000">
@@ -9753,7 +11345,7 @@
             <a:r>
               <a:rPr lang="en-US" sz="1800" b="1" dirty="0">
                 <a:solidFill>
-                  <a:schemeClr val="accent3"/>
+                  <a:schemeClr val="accent2"/>
                 </a:solidFill>
               </a:rPr>
               <a:t>النباتات تستفيد من الحيوانات</a:t>
@@ -9771,7 +11363,7 @@
             <a:r>
               <a:rPr lang="en-US" sz="1800" dirty="0">
                 <a:solidFill>
-                  <a:schemeClr val="bg1"/>
+                  <a:schemeClr val="tx1"/>
                 </a:solidFill>
               </a:rPr>
               <a:t>تنقل بذورها إلى أماكن جديدة.</a:t>
@@ -9789,7 +11381,7 @@
             <a:r>
               <a:rPr lang="en-US" sz="1800" dirty="0">
                 <a:solidFill>
-                  <a:schemeClr val="bg1"/>
+                  <a:schemeClr val="tx1"/>
                 </a:solidFill>
               </a:rPr>
               <a:t>تنقل حبوب اللقاح بين الأزهار.</a:t>
@@ -9807,7 +11399,7 @@
             <a:r>
               <a:rPr lang="en-US" sz="1800" dirty="0">
                 <a:solidFill>
-                  <a:schemeClr val="bg1"/>
+                  <a:schemeClr val="tx1"/>
                 </a:solidFill>
               </a:rPr>
               <a:t>فضلاتها تُغذّي التربة.</a:t>
@@ -9866,6 +11458,18 @@
   <p:clrMapOvr>
     <a:masterClrMapping/>
   </p:clrMapOvr>
+  <mc:AlternateContent xmlns:mc="http://schemas.openxmlformats.org/markup-compatibility/2006">
+    <mc:Choice xmlns:p14="http://schemas.microsoft.com/office/powerpoint/2010/main" Requires="p14">
+      <p:transition spd="slow" p14:dur="1400">
+        <p14:gallery dir="l"/>
+      </p:transition>
+    </mc:Choice>
+    <mc:Fallback>
+      <p:transition spd="slow">
+        <p:push dir="l"/>
+      </p:transition>
+    </mc:Fallback>
+  </mc:AlternateContent>
   <p:timing>
     <p:tnLst>
       <p:par>
@@ -9887,7 +11491,7 @@
                             </p:stCondLst>
                             <p:childTnLst>
                               <p:par>
-                                <p:cTn id="5" presetID="10" presetClass="entr" presetSubtype="0" fill="hold" nodeType="clickEffect">
+                                <p:cTn id="5" presetID="53" presetClass="entr" presetSubtype="16" fill="hold" nodeType="clickEffect">
                                   <p:stCondLst>
                                     <p:cond delay="0"/>
                                   </p:stCondLst>
@@ -9910,9 +11514,65 @@
                                         <p:strVal val="visible"/>
                                       </p:to>
                                     </p:set>
+                                    <p:anim calcmode="lin" valueType="num">
+                                      <p:cBhvr>
+                                        <p:cTn id="7" dur="600" fill="hold"/>
+                                        <p:tgtEl>
+                                          <p:spTgt spid="7"/>
+                                        </p:tgtEl>
+                                        <p:attrNameLst>
+                                          <p:attrName>ppt_w</p:attrName>
+                                        </p:attrNameLst>
+                                      </p:cBhvr>
+                                      <p:tavLst>
+                                        <p:tav tm="0">
+                                          <p:val>
+                                            <p:fltVal val="0"/>
+                                          </p:val>
+                                        </p:tav>
+                                        <p:tav tm="65000">
+                                          <p:val>
+                                            <p:strVal val="#ppt_w*1.15"/>
+                                          </p:val>
+                                        </p:tav>
+                                        <p:tav tm="100000">
+                                          <p:val>
+                                            <p:strVal val="#ppt_w"/>
+                                          </p:val>
+                                        </p:tav>
+                                      </p:tavLst>
+                                    </p:anim>
+                                    <p:anim calcmode="lin" valueType="num">
+                                      <p:cBhvr>
+                                        <p:cTn id="8" dur="600" fill="hold"/>
+                                        <p:tgtEl>
+                                          <p:spTgt spid="7"/>
+                                        </p:tgtEl>
+                                        <p:attrNameLst>
+                                          <p:attrName>ppt_h</p:attrName>
+                                        </p:attrNameLst>
+                                      </p:cBhvr>
+                                      <p:tavLst>
+                                        <p:tav tm="0">
+                                          <p:val>
+                                            <p:fltVal val="0"/>
+                                          </p:val>
+                                        </p:tav>
+                                        <p:tav tm="65000">
+                                          <p:val>
+                                            <p:strVal val="#ppt_h*1.15"/>
+                                          </p:val>
+                                        </p:tav>
+                                        <p:tav tm="100000">
+                                          <p:val>
+                                            <p:strVal val="#ppt_h"/>
+                                          </p:val>
+                                        </p:tav>
+                                      </p:tavLst>
+                                    </p:anim>
                                     <p:animEffect transition="in" filter="fade">
                                       <p:cBhvr>
-                                        <p:cTn id="7" dur="500"/>
+                                        <p:cTn id="9" dur="400"/>
                                         <p:tgtEl>
                                           <p:spTgt spid="7"/>
                                         </p:tgtEl>
@@ -9928,26 +11588,26 @@
                     </p:cTn>
                   </p:par>
                   <p:par>
-                    <p:cTn id="8" fill="hold">
+                    <p:cTn id="10" fill="hold">
                       <p:stCondLst>
                         <p:cond delay="indefinite"/>
                       </p:stCondLst>
                       <p:childTnLst>
                         <p:par>
-                          <p:cTn id="9" fill="hold">
+                          <p:cTn id="11" fill="hold">
                             <p:stCondLst>
                               <p:cond delay="0"/>
                             </p:stCondLst>
                             <p:childTnLst>
                               <p:par>
-                                <p:cTn id="10" presetID="10" presetClass="entr" presetSubtype="0" fill="hold" nodeType="clickEffect">
+                                <p:cTn id="12" presetID="53" presetClass="entr" presetSubtype="16" fill="hold" nodeType="clickEffect">
                                   <p:stCondLst>
                                     <p:cond delay="0"/>
                                   </p:stCondLst>
                                   <p:childTnLst>
                                     <p:set>
                                       <p:cBhvr>
-                                        <p:cTn id="11" dur="1" fill="hold">
+                                        <p:cTn id="13" dur="1" fill="hold">
                                           <p:stCondLst>
                                             <p:cond delay="0"/>
                                           </p:stCondLst>
@@ -9963,9 +11623,65 @@
                                         <p:strVal val="visible"/>
                                       </p:to>
                                     </p:set>
+                                    <p:anim calcmode="lin" valueType="num">
+                                      <p:cBhvr>
+                                        <p:cTn id="14" dur="600" fill="hold"/>
+                                        <p:tgtEl>
+                                          <p:spTgt spid="8"/>
+                                        </p:tgtEl>
+                                        <p:attrNameLst>
+                                          <p:attrName>ppt_w</p:attrName>
+                                        </p:attrNameLst>
+                                      </p:cBhvr>
+                                      <p:tavLst>
+                                        <p:tav tm="0">
+                                          <p:val>
+                                            <p:fltVal val="0"/>
+                                          </p:val>
+                                        </p:tav>
+                                        <p:tav tm="65000">
+                                          <p:val>
+                                            <p:strVal val="#ppt_w*1.15"/>
+                                          </p:val>
+                                        </p:tav>
+                                        <p:tav tm="100000">
+                                          <p:val>
+                                            <p:strVal val="#ppt_w"/>
+                                          </p:val>
+                                        </p:tav>
+                                      </p:tavLst>
+                                    </p:anim>
+                                    <p:anim calcmode="lin" valueType="num">
+                                      <p:cBhvr>
+                                        <p:cTn id="15" dur="600" fill="hold"/>
+                                        <p:tgtEl>
+                                          <p:spTgt spid="8"/>
+                                        </p:tgtEl>
+                                        <p:attrNameLst>
+                                          <p:attrName>ppt_h</p:attrName>
+                                        </p:attrNameLst>
+                                      </p:cBhvr>
+                                      <p:tavLst>
+                                        <p:tav tm="0">
+                                          <p:val>
+                                            <p:fltVal val="0"/>
+                                          </p:val>
+                                        </p:tav>
+                                        <p:tav tm="65000">
+                                          <p:val>
+                                            <p:strVal val="#ppt_h*1.15"/>
+                                          </p:val>
+                                        </p:tav>
+                                        <p:tav tm="100000">
+                                          <p:val>
+                                            <p:strVal val="#ppt_h"/>
+                                          </p:val>
+                                        </p:tav>
+                                      </p:tavLst>
+                                    </p:anim>
                                     <p:animEffect transition="in" filter="fade">
                                       <p:cBhvr>
-                                        <p:cTn id="12" dur="500"/>
+                                        <p:cTn id="16" dur="400"/>
                                         <p:tgtEl>
                                           <p:spTgt spid="8"/>
                                         </p:tgtEl>
@@ -10404,9 +12120,9 @@
             </a:avLst>
           </a:prstGeom>
           <a:solidFill>
-            <a:schemeClr val="accent1"/>
+            <a:schemeClr val="accent6"/>
           </a:solidFill>
-          <a:ln w="12700">
+          <a:ln w="19050">
             <a:solidFill>
               <a:schemeClr val="accent1"/>
             </a:solidFill>
@@ -10490,7 +12206,7 @@
             <a:r>
               <a:rPr lang="en-US" sz="1800" b="1" dirty="0">
                 <a:solidFill>
-                  <a:schemeClr val="bg1"/>
+                  <a:schemeClr val="tx1"/>
                 </a:solidFill>
               </a:rPr>
               <a:t>الشمس</a:t>
@@ -10526,7 +12242,7 @@
             <a:r>
               <a:rPr lang="en-US" sz="2800" b="1" dirty="0">
                 <a:solidFill>
-                  <a:schemeClr val="accent3"/>
+                  <a:schemeClr val="accent2"/>
                 </a:solidFill>
               </a:rPr>
               <a:t>←</a:t>
@@ -10611,7 +12327,7 @@
             <a:r>
               <a:rPr lang="en-US" sz="1800" b="1" dirty="0">
                 <a:solidFill>
-                  <a:schemeClr val="bg1"/>
+                  <a:schemeClr val="tx1"/>
                 </a:solidFill>
               </a:rPr>
               <a:t>أعشاب</a:t>
@@ -10647,7 +12363,7 @@
             <a:r>
               <a:rPr lang="en-US" sz="2800" b="1" dirty="0">
                 <a:solidFill>
-                  <a:schemeClr val="accent3"/>
+                  <a:schemeClr val="accent2"/>
                 </a:solidFill>
               </a:rPr>
               <a:t>←</a:t>
@@ -10732,7 +12448,7 @@
             <a:r>
               <a:rPr lang="en-US" sz="1800" b="1" dirty="0">
                 <a:solidFill>
-                  <a:schemeClr val="bg1"/>
+                  <a:schemeClr val="tx1"/>
                 </a:solidFill>
               </a:rPr>
               <a:t>أرنب</a:t>
@@ -10768,7 +12484,7 @@
             <a:r>
               <a:rPr lang="en-US" sz="2800" b="1" dirty="0">
                 <a:solidFill>
-                  <a:schemeClr val="accent3"/>
+                  <a:schemeClr val="accent2"/>
                 </a:solidFill>
               </a:rPr>
               <a:t>←</a:t>
@@ -10853,7 +12569,7 @@
             <a:r>
               <a:rPr lang="en-US" sz="1800" b="1" dirty="0">
                 <a:solidFill>
-                  <a:schemeClr val="bg1"/>
+                  <a:schemeClr val="tx1"/>
                 </a:solidFill>
               </a:rPr>
               <a:t>ثعلب</a:t>
@@ -10912,6 +12628,18 @@
   <p:clrMapOvr>
     <a:masterClrMapping/>
   </p:clrMapOvr>
+  <mc:AlternateContent xmlns:mc="http://schemas.openxmlformats.org/markup-compatibility/2006">
+    <mc:Choice xmlns:p14="http://schemas.microsoft.com/office/powerpoint/2010/main" Requires="p14">
+      <p:transition spd="slow" p14:dur="1400">
+        <p14:conveyor dir="l"/>
+      </p:transition>
+    </mc:Choice>
+    <mc:Fallback>
+      <p:transition spd="slow">
+        <p:cover dir="l"/>
+      </p:transition>
+    </mc:Fallback>
+  </mc:AlternateContent>
   <p:timing>
     <p:tnLst>
       <p:par>
@@ -10933,7 +12661,7 @@
                             </p:stCondLst>
                             <p:childTnLst>
                               <p:par>
-                                <p:cTn id="5" presetID="10" presetClass="entr" presetSubtype="0" fill="hold" nodeType="clickEffect">
+                                <p:cTn id="5" presetID="53" presetClass="entr" presetSubtype="16" fill="hold" nodeType="clickEffect">
                                   <p:stCondLst>
                                     <p:cond delay="0"/>
                                   </p:stCondLst>
@@ -10956,9 +12684,65 @@
                                         <p:strVal val="visible"/>
                                       </p:to>
                                     </p:set>
+                                    <p:anim calcmode="lin" valueType="num">
+                                      <p:cBhvr>
+                                        <p:cTn id="7" dur="600" fill="hold"/>
+                                        <p:tgtEl>
+                                          <p:spTgt spid="11"/>
+                                        </p:tgtEl>
+                                        <p:attrNameLst>
+                                          <p:attrName>ppt_w</p:attrName>
+                                        </p:attrNameLst>
+                                      </p:cBhvr>
+                                      <p:tavLst>
+                                        <p:tav tm="0">
+                                          <p:val>
+                                            <p:fltVal val="0"/>
+                                          </p:val>
+                                        </p:tav>
+                                        <p:tav tm="65000">
+                                          <p:val>
+                                            <p:strVal val="#ppt_w*1.15"/>
+                                          </p:val>
+                                        </p:tav>
+                                        <p:tav tm="100000">
+                                          <p:val>
+                                            <p:strVal val="#ppt_w"/>
+                                          </p:val>
+                                        </p:tav>
+                                      </p:tavLst>
+                                    </p:anim>
+                                    <p:anim calcmode="lin" valueType="num">
+                                      <p:cBhvr>
+                                        <p:cTn id="8" dur="600" fill="hold"/>
+                                        <p:tgtEl>
+                                          <p:spTgt spid="11"/>
+                                        </p:tgtEl>
+                                        <p:attrNameLst>
+                                          <p:attrName>ppt_h</p:attrName>
+                                        </p:attrNameLst>
+                                      </p:cBhvr>
+                                      <p:tavLst>
+                                        <p:tav tm="0">
+                                          <p:val>
+                                            <p:fltVal val="0"/>
+                                          </p:val>
+                                        </p:tav>
+                                        <p:tav tm="65000">
+                                          <p:val>
+                                            <p:strVal val="#ppt_h*1.15"/>
+                                          </p:val>
+                                        </p:tav>
+                                        <p:tav tm="100000">
+                                          <p:val>
+                                            <p:strVal val="#ppt_h"/>
+                                          </p:val>
+                                        </p:tav>
+                                      </p:tavLst>
+                                    </p:anim>
                                     <p:animEffect transition="in" filter="fade">
                                       <p:cBhvr>
-                                        <p:cTn id="7" dur="500"/>
+                                        <p:cTn id="9" dur="400"/>
                                         <p:tgtEl>
                                           <p:spTgt spid="11"/>
                                         </p:tgtEl>
@@ -10968,14 +12752,14 @@
                                 </p:cTn>
                               </p:par>
                               <p:par>
-                                <p:cTn id="8" presetID="10" presetClass="entr" presetSubtype="0" fill="hold" nodeType="withEffect">
+                                <p:cTn id="10" presetID="53" presetClass="entr" presetSubtype="16" fill="hold" nodeType="withEffect">
                                   <p:stCondLst>
                                     <p:cond delay="0"/>
                                   </p:stCondLst>
                                   <p:childTnLst>
                                     <p:set>
                                       <p:cBhvr>
-                                        <p:cTn id="9" dur="1" fill="hold">
+                                        <p:cTn id="11" dur="1" fill="hold">
                                           <p:stCondLst>
                                             <p:cond delay="0"/>
                                           </p:stCondLst>
@@ -10991,9 +12775,65 @@
                                         <p:strVal val="visible"/>
                                       </p:to>
                                     </p:set>
+                                    <p:anim calcmode="lin" valueType="num">
+                                      <p:cBhvr>
+                                        <p:cTn id="12" dur="600" fill="hold"/>
+                                        <p:tgtEl>
+                                          <p:spTgt spid="12"/>
+                                        </p:tgtEl>
+                                        <p:attrNameLst>
+                                          <p:attrName>ppt_w</p:attrName>
+                                        </p:attrNameLst>
+                                      </p:cBhvr>
+                                      <p:tavLst>
+                                        <p:tav tm="0">
+                                          <p:val>
+                                            <p:fltVal val="0"/>
+                                          </p:val>
+                                        </p:tav>
+                                        <p:tav tm="65000">
+                                          <p:val>
+                                            <p:strVal val="#ppt_w*1.15"/>
+                                          </p:val>
+                                        </p:tav>
+                                        <p:tav tm="100000">
+                                          <p:val>
+                                            <p:strVal val="#ppt_w"/>
+                                          </p:val>
+                                        </p:tav>
+                                      </p:tavLst>
+                                    </p:anim>
+                                    <p:anim calcmode="lin" valueType="num">
+                                      <p:cBhvr>
+                                        <p:cTn id="13" dur="600" fill="hold"/>
+                                        <p:tgtEl>
+                                          <p:spTgt spid="12"/>
+                                        </p:tgtEl>
+                                        <p:attrNameLst>
+                                          <p:attrName>ppt_h</p:attrName>
+                                        </p:attrNameLst>
+                                      </p:cBhvr>
+                                      <p:tavLst>
+                                        <p:tav tm="0">
+                                          <p:val>
+                                            <p:fltVal val="0"/>
+                                          </p:val>
+                                        </p:tav>
+                                        <p:tav tm="65000">
+                                          <p:val>
+                                            <p:strVal val="#ppt_h*1.15"/>
+                                          </p:val>
+                                        </p:tav>
+                                        <p:tav tm="100000">
+                                          <p:val>
+                                            <p:strVal val="#ppt_h"/>
+                                          </p:val>
+                                        </p:tav>
+                                      </p:tavLst>
+                                    </p:anim>
                                     <p:animEffect transition="in" filter="fade">
                                       <p:cBhvr>
-                                        <p:cTn id="10" dur="500"/>
+                                        <p:cTn id="14" dur="400"/>
                                         <p:tgtEl>
                                           <p:spTgt spid="12"/>
                                         </p:tgtEl>
@@ -11003,14 +12843,14 @@
                                 </p:cTn>
                               </p:par>
                               <p:par>
-                                <p:cTn id="11" presetID="10" presetClass="entr" presetSubtype="0" fill="hold" nodeType="withEffect">
+                                <p:cTn id="15" presetID="53" presetClass="entr" presetSubtype="16" fill="hold" nodeType="withEffect">
                                   <p:stCondLst>
                                     <p:cond delay="0"/>
                                   </p:stCondLst>
                                   <p:childTnLst>
                                     <p:set>
                                       <p:cBhvr>
-                                        <p:cTn id="12" dur="1" fill="hold">
+                                        <p:cTn id="16" dur="1" fill="hold">
                                           <p:stCondLst>
                                             <p:cond delay="0"/>
                                           </p:stCondLst>
@@ -11026,9 +12866,65 @@
                                         <p:strVal val="visible"/>
                                       </p:to>
                                     </p:set>
+                                    <p:anim calcmode="lin" valueType="num">
+                                      <p:cBhvr>
+                                        <p:cTn id="17" dur="600" fill="hold"/>
+                                        <p:tgtEl>
+                                          <p:spTgt spid="13"/>
+                                        </p:tgtEl>
+                                        <p:attrNameLst>
+                                          <p:attrName>ppt_w</p:attrName>
+                                        </p:attrNameLst>
+                                      </p:cBhvr>
+                                      <p:tavLst>
+                                        <p:tav tm="0">
+                                          <p:val>
+                                            <p:fltVal val="0"/>
+                                          </p:val>
+                                        </p:tav>
+                                        <p:tav tm="65000">
+                                          <p:val>
+                                            <p:strVal val="#ppt_w*1.15"/>
+                                          </p:val>
+                                        </p:tav>
+                                        <p:tav tm="100000">
+                                          <p:val>
+                                            <p:strVal val="#ppt_w"/>
+                                          </p:val>
+                                        </p:tav>
+                                      </p:tavLst>
+                                    </p:anim>
+                                    <p:anim calcmode="lin" valueType="num">
+                                      <p:cBhvr>
+                                        <p:cTn id="18" dur="600" fill="hold"/>
+                                        <p:tgtEl>
+                                          <p:spTgt spid="13"/>
+                                        </p:tgtEl>
+                                        <p:attrNameLst>
+                                          <p:attrName>ppt_h</p:attrName>
+                                        </p:attrNameLst>
+                                      </p:cBhvr>
+                                      <p:tavLst>
+                                        <p:tav tm="0">
+                                          <p:val>
+                                            <p:fltVal val="0"/>
+                                          </p:val>
+                                        </p:tav>
+                                        <p:tav tm="65000">
+                                          <p:val>
+                                            <p:strVal val="#ppt_h*1.15"/>
+                                          </p:val>
+                                        </p:tav>
+                                        <p:tav tm="100000">
+                                          <p:val>
+                                            <p:strVal val="#ppt_h"/>
+                                          </p:val>
+                                        </p:tav>
+                                      </p:tavLst>
+                                    </p:anim>
                                     <p:animEffect transition="in" filter="fade">
                                       <p:cBhvr>
-                                        <p:cTn id="13" dur="500"/>
+                                        <p:cTn id="19" dur="400"/>
                                         <p:tgtEl>
                                           <p:spTgt spid="13"/>
                                         </p:tgtEl>
@@ -11038,14 +12934,14 @@
                                 </p:cTn>
                               </p:par>
                               <p:par>
-                                <p:cTn id="14" presetID="10" presetClass="entr" presetSubtype="0" fill="hold" nodeType="withEffect">
+                                <p:cTn id="20" presetID="53" presetClass="entr" presetSubtype="16" fill="hold" nodeType="withEffect">
                                   <p:stCondLst>
                                     <p:cond delay="0"/>
                                   </p:stCondLst>
                                   <p:childTnLst>
                                     <p:set>
                                       <p:cBhvr>
-                                        <p:cTn id="15" dur="1" fill="hold">
+                                        <p:cTn id="21" dur="1" fill="hold">
                                           <p:stCondLst>
                                             <p:cond delay="0"/>
                                           </p:stCondLst>
@@ -11061,9 +12957,65 @@
                                         <p:strVal val="visible"/>
                                       </p:to>
                                     </p:set>
+                                    <p:anim calcmode="lin" valueType="num">
+                                      <p:cBhvr>
+                                        <p:cTn id="22" dur="600" fill="hold"/>
+                                        <p:tgtEl>
+                                          <p:spTgt spid="14"/>
+                                        </p:tgtEl>
+                                        <p:attrNameLst>
+                                          <p:attrName>ppt_w</p:attrName>
+                                        </p:attrNameLst>
+                                      </p:cBhvr>
+                                      <p:tavLst>
+                                        <p:tav tm="0">
+                                          <p:val>
+                                            <p:fltVal val="0"/>
+                                          </p:val>
+                                        </p:tav>
+                                        <p:tav tm="65000">
+                                          <p:val>
+                                            <p:strVal val="#ppt_w*1.15"/>
+                                          </p:val>
+                                        </p:tav>
+                                        <p:tav tm="100000">
+                                          <p:val>
+                                            <p:strVal val="#ppt_w"/>
+                                          </p:val>
+                                        </p:tav>
+                                      </p:tavLst>
+                                    </p:anim>
+                                    <p:anim calcmode="lin" valueType="num">
+                                      <p:cBhvr>
+                                        <p:cTn id="23" dur="600" fill="hold"/>
+                                        <p:tgtEl>
+                                          <p:spTgt spid="14"/>
+                                        </p:tgtEl>
+                                        <p:attrNameLst>
+                                          <p:attrName>ppt_h</p:attrName>
+                                        </p:attrNameLst>
+                                      </p:cBhvr>
+                                      <p:tavLst>
+                                        <p:tav tm="0">
+                                          <p:val>
+                                            <p:fltVal val="0"/>
+                                          </p:val>
+                                        </p:tav>
+                                        <p:tav tm="65000">
+                                          <p:val>
+                                            <p:strVal val="#ppt_h*1.15"/>
+                                          </p:val>
+                                        </p:tav>
+                                        <p:tav tm="100000">
+                                          <p:val>
+                                            <p:strVal val="#ppt_h"/>
+                                          </p:val>
+                                        </p:tav>
+                                      </p:tavLst>
+                                    </p:anim>
                                     <p:animEffect transition="in" filter="fade">
                                       <p:cBhvr>
-                                        <p:cTn id="16" dur="500"/>
+                                        <p:cTn id="24" dur="400"/>
                                         <p:tgtEl>
                                           <p:spTgt spid="14"/>
                                         </p:tgtEl>
@@ -11073,14 +13025,14 @@
                                 </p:cTn>
                               </p:par>
                               <p:par>
-                                <p:cTn id="17" presetID="10" presetClass="entr" presetSubtype="0" fill="hold" nodeType="withEffect">
+                                <p:cTn id="25" presetID="53" presetClass="entr" presetSubtype="16" fill="hold" nodeType="withEffect">
                                   <p:stCondLst>
                                     <p:cond delay="0"/>
                                   </p:stCondLst>
                                   <p:childTnLst>
                                     <p:set>
                                       <p:cBhvr>
-                                        <p:cTn id="18" dur="1" fill="hold">
+                                        <p:cTn id="26" dur="1" fill="hold">
                                           <p:stCondLst>
                                             <p:cond delay="0"/>
                                           </p:stCondLst>
@@ -11096,9 +13048,65 @@
                                         <p:strVal val="visible"/>
                                       </p:to>
                                     </p:set>
+                                    <p:anim calcmode="lin" valueType="num">
+                                      <p:cBhvr>
+                                        <p:cTn id="27" dur="600" fill="hold"/>
+                                        <p:tgtEl>
+                                          <p:spTgt spid="15"/>
+                                        </p:tgtEl>
+                                        <p:attrNameLst>
+                                          <p:attrName>ppt_w</p:attrName>
+                                        </p:attrNameLst>
+                                      </p:cBhvr>
+                                      <p:tavLst>
+                                        <p:tav tm="0">
+                                          <p:val>
+                                            <p:fltVal val="0"/>
+                                          </p:val>
+                                        </p:tav>
+                                        <p:tav tm="65000">
+                                          <p:val>
+                                            <p:strVal val="#ppt_w*1.15"/>
+                                          </p:val>
+                                        </p:tav>
+                                        <p:tav tm="100000">
+                                          <p:val>
+                                            <p:strVal val="#ppt_w"/>
+                                          </p:val>
+                                        </p:tav>
+                                      </p:tavLst>
+                                    </p:anim>
+                                    <p:anim calcmode="lin" valueType="num">
+                                      <p:cBhvr>
+                                        <p:cTn id="28" dur="600" fill="hold"/>
+                                        <p:tgtEl>
+                                          <p:spTgt spid="15"/>
+                                        </p:tgtEl>
+                                        <p:attrNameLst>
+                                          <p:attrName>ppt_h</p:attrName>
+                                        </p:attrNameLst>
+                                      </p:cBhvr>
+                                      <p:tavLst>
+                                        <p:tav tm="0">
+                                          <p:val>
+                                            <p:fltVal val="0"/>
+                                          </p:val>
+                                        </p:tav>
+                                        <p:tav tm="65000">
+                                          <p:val>
+                                            <p:strVal val="#ppt_h*1.15"/>
+                                          </p:val>
+                                        </p:tav>
+                                        <p:tav tm="100000">
+                                          <p:val>
+                                            <p:strVal val="#ppt_h"/>
+                                          </p:val>
+                                        </p:tav>
+                                      </p:tavLst>
+                                    </p:anim>
                                     <p:animEffect transition="in" filter="fade">
                                       <p:cBhvr>
-                                        <p:cTn id="19" dur="500"/>
+                                        <p:cTn id="29" dur="400"/>
                                         <p:tgtEl>
                                           <p:spTgt spid="15"/>
                                         </p:tgtEl>
@@ -11108,14 +13116,14 @@
                                 </p:cTn>
                               </p:par>
                               <p:par>
-                                <p:cTn id="20" presetID="10" presetClass="entr" presetSubtype="0" fill="hold" nodeType="withEffect">
+                                <p:cTn id="30" presetID="53" presetClass="entr" presetSubtype="16" fill="hold" nodeType="withEffect">
                                   <p:stCondLst>
                                     <p:cond delay="0"/>
                                   </p:stCondLst>
                                   <p:childTnLst>
                                     <p:set>
                                       <p:cBhvr>
-                                        <p:cTn id="21" dur="1" fill="hold">
+                                        <p:cTn id="31" dur="1" fill="hold">
                                           <p:stCondLst>
                                             <p:cond delay="0"/>
                                           </p:stCondLst>
@@ -11131,9 +13139,65 @@
                                         <p:strVal val="visible"/>
                                       </p:to>
                                     </p:set>
+                                    <p:anim calcmode="lin" valueType="num">
+                                      <p:cBhvr>
+                                        <p:cTn id="32" dur="600" fill="hold"/>
+                                        <p:tgtEl>
+                                          <p:spTgt spid="16"/>
+                                        </p:tgtEl>
+                                        <p:attrNameLst>
+                                          <p:attrName>ppt_w</p:attrName>
+                                        </p:attrNameLst>
+                                      </p:cBhvr>
+                                      <p:tavLst>
+                                        <p:tav tm="0">
+                                          <p:val>
+                                            <p:fltVal val="0"/>
+                                          </p:val>
+                                        </p:tav>
+                                        <p:tav tm="65000">
+                                          <p:val>
+                                            <p:strVal val="#ppt_w*1.15"/>
+                                          </p:val>
+                                        </p:tav>
+                                        <p:tav tm="100000">
+                                          <p:val>
+                                            <p:strVal val="#ppt_w"/>
+                                          </p:val>
+                                        </p:tav>
+                                      </p:tavLst>
+                                    </p:anim>
+                                    <p:anim calcmode="lin" valueType="num">
+                                      <p:cBhvr>
+                                        <p:cTn id="33" dur="600" fill="hold"/>
+                                        <p:tgtEl>
+                                          <p:spTgt spid="16"/>
+                                        </p:tgtEl>
+                                        <p:attrNameLst>
+                                          <p:attrName>ppt_h</p:attrName>
+                                        </p:attrNameLst>
+                                      </p:cBhvr>
+                                      <p:tavLst>
+                                        <p:tav tm="0">
+                                          <p:val>
+                                            <p:fltVal val="0"/>
+                                          </p:val>
+                                        </p:tav>
+                                        <p:tav tm="65000">
+                                          <p:val>
+                                            <p:strVal val="#ppt_h*1.15"/>
+                                          </p:val>
+                                        </p:tav>
+                                        <p:tav tm="100000">
+                                          <p:val>
+                                            <p:strVal val="#ppt_h"/>
+                                          </p:val>
+                                        </p:tav>
+                                      </p:tavLst>
+                                    </p:anim>
                                     <p:animEffect transition="in" filter="fade">
                                       <p:cBhvr>
-                                        <p:cTn id="22" dur="500"/>
+                                        <p:cTn id="34" dur="400"/>
                                         <p:tgtEl>
                                           <p:spTgt spid="16"/>
                                         </p:tgtEl>
@@ -11143,14 +13207,14 @@
                                 </p:cTn>
                               </p:par>
                               <p:par>
-                                <p:cTn id="23" presetID="10" presetClass="entr" presetSubtype="0" fill="hold" nodeType="withEffect">
+                                <p:cTn id="35" presetID="53" presetClass="entr" presetSubtype="16" fill="hold" nodeType="withEffect">
                                   <p:stCondLst>
                                     <p:cond delay="0"/>
                                   </p:stCondLst>
                                   <p:childTnLst>
                                     <p:set>
                                       <p:cBhvr>
-                                        <p:cTn id="24" dur="1" fill="hold">
+                                        <p:cTn id="36" dur="1" fill="hold">
                                           <p:stCondLst>
                                             <p:cond delay="0"/>
                                           </p:stCondLst>
@@ -11166,9 +13230,65 @@
                                         <p:strVal val="visible"/>
                                       </p:to>
                                     </p:set>
+                                    <p:anim calcmode="lin" valueType="num">
+                                      <p:cBhvr>
+                                        <p:cTn id="37" dur="600" fill="hold"/>
+                                        <p:tgtEl>
+                                          <p:spTgt spid="17"/>
+                                        </p:tgtEl>
+                                        <p:attrNameLst>
+                                          <p:attrName>ppt_w</p:attrName>
+                                        </p:attrNameLst>
+                                      </p:cBhvr>
+                                      <p:tavLst>
+                                        <p:tav tm="0">
+                                          <p:val>
+                                            <p:fltVal val="0"/>
+                                          </p:val>
+                                        </p:tav>
+                                        <p:tav tm="65000">
+                                          <p:val>
+                                            <p:strVal val="#ppt_w*1.15"/>
+                                          </p:val>
+                                        </p:tav>
+                                        <p:tav tm="100000">
+                                          <p:val>
+                                            <p:strVal val="#ppt_w"/>
+                                          </p:val>
+                                        </p:tav>
+                                      </p:tavLst>
+                                    </p:anim>
+                                    <p:anim calcmode="lin" valueType="num">
+                                      <p:cBhvr>
+                                        <p:cTn id="38" dur="600" fill="hold"/>
+                                        <p:tgtEl>
+                                          <p:spTgt spid="17"/>
+                                        </p:tgtEl>
+                                        <p:attrNameLst>
+                                          <p:attrName>ppt_h</p:attrName>
+                                        </p:attrNameLst>
+                                      </p:cBhvr>
+                                      <p:tavLst>
+                                        <p:tav tm="0">
+                                          <p:val>
+                                            <p:fltVal val="0"/>
+                                          </p:val>
+                                        </p:tav>
+                                        <p:tav tm="65000">
+                                          <p:val>
+                                            <p:strVal val="#ppt_h*1.15"/>
+                                          </p:val>
+                                        </p:tav>
+                                        <p:tav tm="100000">
+                                          <p:val>
+                                            <p:strVal val="#ppt_h"/>
+                                          </p:val>
+                                        </p:tav>
+                                      </p:tavLst>
+                                    </p:anim>
                                     <p:animEffect transition="in" filter="fade">
                                       <p:cBhvr>
-                                        <p:cTn id="25" dur="500"/>
+                                        <p:cTn id="39" dur="400"/>
                                         <p:tgtEl>
                                           <p:spTgt spid="17"/>
                                         </p:tgtEl>
@@ -11178,14 +13298,14 @@
                                 </p:cTn>
                               </p:par>
                               <p:par>
-                                <p:cTn id="26" presetID="10" presetClass="entr" presetSubtype="0" fill="hold" nodeType="withEffect">
+                                <p:cTn id="40" presetID="53" presetClass="entr" presetSubtype="16" fill="hold" nodeType="withEffect">
                                   <p:stCondLst>
                                     <p:cond delay="0"/>
                                   </p:stCondLst>
                                   <p:childTnLst>
                                     <p:set>
                                       <p:cBhvr>
-                                        <p:cTn id="27" dur="1" fill="hold">
+                                        <p:cTn id="41" dur="1" fill="hold">
                                           <p:stCondLst>
                                             <p:cond delay="0"/>
                                           </p:stCondLst>
@@ -11201,9 +13321,65 @@
                                         <p:strVal val="visible"/>
                                       </p:to>
                                     </p:set>
+                                    <p:anim calcmode="lin" valueType="num">
+                                      <p:cBhvr>
+                                        <p:cTn id="42" dur="600" fill="hold"/>
+                                        <p:tgtEl>
+                                          <p:spTgt spid="18"/>
+                                        </p:tgtEl>
+                                        <p:attrNameLst>
+                                          <p:attrName>ppt_w</p:attrName>
+                                        </p:attrNameLst>
+                                      </p:cBhvr>
+                                      <p:tavLst>
+                                        <p:tav tm="0">
+                                          <p:val>
+                                            <p:fltVal val="0"/>
+                                          </p:val>
+                                        </p:tav>
+                                        <p:tav tm="65000">
+                                          <p:val>
+                                            <p:strVal val="#ppt_w*1.15"/>
+                                          </p:val>
+                                        </p:tav>
+                                        <p:tav tm="100000">
+                                          <p:val>
+                                            <p:strVal val="#ppt_w"/>
+                                          </p:val>
+                                        </p:tav>
+                                      </p:tavLst>
+                                    </p:anim>
+                                    <p:anim calcmode="lin" valueType="num">
+                                      <p:cBhvr>
+                                        <p:cTn id="43" dur="600" fill="hold"/>
+                                        <p:tgtEl>
+                                          <p:spTgt spid="18"/>
+                                        </p:tgtEl>
+                                        <p:attrNameLst>
+                                          <p:attrName>ppt_h</p:attrName>
+                                        </p:attrNameLst>
+                                      </p:cBhvr>
+                                      <p:tavLst>
+                                        <p:tav tm="0">
+                                          <p:val>
+                                            <p:fltVal val="0"/>
+                                          </p:val>
+                                        </p:tav>
+                                        <p:tav tm="65000">
+                                          <p:val>
+                                            <p:strVal val="#ppt_h*1.15"/>
+                                          </p:val>
+                                        </p:tav>
+                                        <p:tav tm="100000">
+                                          <p:val>
+                                            <p:strVal val="#ppt_h"/>
+                                          </p:val>
+                                        </p:tav>
+                                      </p:tavLst>
+                                    </p:anim>
                                     <p:animEffect transition="in" filter="fade">
                                       <p:cBhvr>
-                                        <p:cTn id="28" dur="500"/>
+                                        <p:cTn id="44" dur="400"/>
                                         <p:tgtEl>
                                           <p:spTgt spid="18"/>
                                         </p:tgtEl>
@@ -11213,14 +13389,14 @@
                                 </p:cTn>
                               </p:par>
                               <p:par>
-                                <p:cTn id="29" presetID="10" presetClass="entr" presetSubtype="0" fill="hold" nodeType="withEffect">
+                                <p:cTn id="45" presetID="53" presetClass="entr" presetSubtype="16" fill="hold" nodeType="withEffect">
                                   <p:stCondLst>
                                     <p:cond delay="0"/>
                                   </p:stCondLst>
                                   <p:childTnLst>
                                     <p:set>
                                       <p:cBhvr>
-                                        <p:cTn id="30" dur="1" fill="hold">
+                                        <p:cTn id="46" dur="1" fill="hold">
                                           <p:stCondLst>
                                             <p:cond delay="0"/>
                                           </p:stCondLst>
@@ -11236,9 +13412,65 @@
                                         <p:strVal val="visible"/>
                                       </p:to>
                                     </p:set>
+                                    <p:anim calcmode="lin" valueType="num">
+                                      <p:cBhvr>
+                                        <p:cTn id="47" dur="600" fill="hold"/>
+                                        <p:tgtEl>
+                                          <p:spTgt spid="19"/>
+                                        </p:tgtEl>
+                                        <p:attrNameLst>
+                                          <p:attrName>ppt_w</p:attrName>
+                                        </p:attrNameLst>
+                                      </p:cBhvr>
+                                      <p:tavLst>
+                                        <p:tav tm="0">
+                                          <p:val>
+                                            <p:fltVal val="0"/>
+                                          </p:val>
+                                        </p:tav>
+                                        <p:tav tm="65000">
+                                          <p:val>
+                                            <p:strVal val="#ppt_w*1.15"/>
+                                          </p:val>
+                                        </p:tav>
+                                        <p:tav tm="100000">
+                                          <p:val>
+                                            <p:strVal val="#ppt_w"/>
+                                          </p:val>
+                                        </p:tav>
+                                      </p:tavLst>
+                                    </p:anim>
+                                    <p:anim calcmode="lin" valueType="num">
+                                      <p:cBhvr>
+                                        <p:cTn id="48" dur="600" fill="hold"/>
+                                        <p:tgtEl>
+                                          <p:spTgt spid="19"/>
+                                        </p:tgtEl>
+                                        <p:attrNameLst>
+                                          <p:attrName>ppt_h</p:attrName>
+                                        </p:attrNameLst>
+                                      </p:cBhvr>
+                                      <p:tavLst>
+                                        <p:tav tm="0">
+                                          <p:val>
+                                            <p:fltVal val="0"/>
+                                          </p:val>
+                                        </p:tav>
+                                        <p:tav tm="65000">
+                                          <p:val>
+                                            <p:strVal val="#ppt_h*1.15"/>
+                                          </p:val>
+                                        </p:tav>
+                                        <p:tav tm="100000">
+                                          <p:val>
+                                            <p:strVal val="#ppt_h"/>
+                                          </p:val>
+                                        </p:tav>
+                                      </p:tavLst>
+                                    </p:anim>
                                     <p:animEffect transition="in" filter="fade">
                                       <p:cBhvr>
-                                        <p:cTn id="31" dur="500"/>
+                                        <p:cTn id="49" dur="400"/>
                                         <p:tgtEl>
                                           <p:spTgt spid="19"/>
                                         </p:tgtEl>
@@ -11248,14 +13480,14 @@
                                 </p:cTn>
                               </p:par>
                               <p:par>
-                                <p:cTn id="32" presetID="10" presetClass="entr" presetSubtype="0" fill="hold" nodeType="withEffect">
+                                <p:cTn id="50" presetID="53" presetClass="entr" presetSubtype="16" fill="hold" nodeType="withEffect">
                                   <p:stCondLst>
                                     <p:cond delay="0"/>
                                   </p:stCondLst>
                                   <p:childTnLst>
                                     <p:set>
                                       <p:cBhvr>
-                                        <p:cTn id="33" dur="1" fill="hold">
+                                        <p:cTn id="51" dur="1" fill="hold">
                                           <p:stCondLst>
                                             <p:cond delay="0"/>
                                           </p:stCondLst>
@@ -11271,9 +13503,65 @@
                                         <p:strVal val="visible"/>
                                       </p:to>
                                     </p:set>
+                                    <p:anim calcmode="lin" valueType="num">
+                                      <p:cBhvr>
+                                        <p:cTn id="52" dur="600" fill="hold"/>
+                                        <p:tgtEl>
+                                          <p:spTgt spid="20"/>
+                                        </p:tgtEl>
+                                        <p:attrNameLst>
+                                          <p:attrName>ppt_w</p:attrName>
+                                        </p:attrNameLst>
+                                      </p:cBhvr>
+                                      <p:tavLst>
+                                        <p:tav tm="0">
+                                          <p:val>
+                                            <p:fltVal val="0"/>
+                                          </p:val>
+                                        </p:tav>
+                                        <p:tav tm="65000">
+                                          <p:val>
+                                            <p:strVal val="#ppt_w*1.15"/>
+                                          </p:val>
+                                        </p:tav>
+                                        <p:tav tm="100000">
+                                          <p:val>
+                                            <p:strVal val="#ppt_w"/>
+                                          </p:val>
+                                        </p:tav>
+                                      </p:tavLst>
+                                    </p:anim>
+                                    <p:anim calcmode="lin" valueType="num">
+                                      <p:cBhvr>
+                                        <p:cTn id="53" dur="600" fill="hold"/>
+                                        <p:tgtEl>
+                                          <p:spTgt spid="20"/>
+                                        </p:tgtEl>
+                                        <p:attrNameLst>
+                                          <p:attrName>ppt_h</p:attrName>
+                                        </p:attrNameLst>
+                                      </p:cBhvr>
+                                      <p:tavLst>
+                                        <p:tav tm="0">
+                                          <p:val>
+                                            <p:fltVal val="0"/>
+                                          </p:val>
+                                        </p:tav>
+                                        <p:tav tm="65000">
+                                          <p:val>
+                                            <p:strVal val="#ppt_h*1.15"/>
+                                          </p:val>
+                                        </p:tav>
+                                        <p:tav tm="100000">
+                                          <p:val>
+                                            <p:strVal val="#ppt_h"/>
+                                          </p:val>
+                                        </p:tav>
+                                      </p:tavLst>
+                                    </p:anim>
                                     <p:animEffect transition="in" filter="fade">
                                       <p:cBhvr>
-                                        <p:cTn id="34" dur="500"/>
+                                        <p:cTn id="54" dur="400"/>
                                         <p:tgtEl>
                                           <p:spTgt spid="20"/>
                                         </p:tgtEl>
@@ -11283,14 +13571,14 @@
                                 </p:cTn>
                               </p:par>
                               <p:par>
-                                <p:cTn id="35" presetID="10" presetClass="entr" presetSubtype="0" fill="hold" nodeType="withEffect">
+                                <p:cTn id="55" presetID="53" presetClass="entr" presetSubtype="16" fill="hold" nodeType="withEffect">
                                   <p:stCondLst>
                                     <p:cond delay="0"/>
                                   </p:stCondLst>
                                   <p:childTnLst>
                                     <p:set>
                                       <p:cBhvr>
-                                        <p:cTn id="36" dur="1" fill="hold">
+                                        <p:cTn id="56" dur="1" fill="hold">
                                           <p:stCondLst>
                                             <p:cond delay="0"/>
                                           </p:stCondLst>
@@ -11306,9 +13594,65 @@
                                         <p:strVal val="visible"/>
                                       </p:to>
                                     </p:set>
+                                    <p:anim calcmode="lin" valueType="num">
+                                      <p:cBhvr>
+                                        <p:cTn id="57" dur="600" fill="hold"/>
+                                        <p:tgtEl>
+                                          <p:spTgt spid="21"/>
+                                        </p:tgtEl>
+                                        <p:attrNameLst>
+                                          <p:attrName>ppt_w</p:attrName>
+                                        </p:attrNameLst>
+                                      </p:cBhvr>
+                                      <p:tavLst>
+                                        <p:tav tm="0">
+                                          <p:val>
+                                            <p:fltVal val="0"/>
+                                          </p:val>
+                                        </p:tav>
+                                        <p:tav tm="65000">
+                                          <p:val>
+                                            <p:strVal val="#ppt_w*1.15"/>
+                                          </p:val>
+                                        </p:tav>
+                                        <p:tav tm="100000">
+                                          <p:val>
+                                            <p:strVal val="#ppt_w"/>
+                                          </p:val>
+                                        </p:tav>
+                                      </p:tavLst>
+                                    </p:anim>
+                                    <p:anim calcmode="lin" valueType="num">
+                                      <p:cBhvr>
+                                        <p:cTn id="58" dur="600" fill="hold"/>
+                                        <p:tgtEl>
+                                          <p:spTgt spid="21"/>
+                                        </p:tgtEl>
+                                        <p:attrNameLst>
+                                          <p:attrName>ppt_h</p:attrName>
+                                        </p:attrNameLst>
+                                      </p:cBhvr>
+                                      <p:tavLst>
+                                        <p:tav tm="0">
+                                          <p:val>
+                                            <p:fltVal val="0"/>
+                                          </p:val>
+                                        </p:tav>
+                                        <p:tav tm="65000">
+                                          <p:val>
+                                            <p:strVal val="#ppt_h*1.15"/>
+                                          </p:val>
+                                        </p:tav>
+                                        <p:tav tm="100000">
+                                          <p:val>
+                                            <p:strVal val="#ppt_h"/>
+                                          </p:val>
+                                        </p:tav>
+                                      </p:tavLst>
+                                    </p:anim>
                                     <p:animEffect transition="in" filter="fade">
                                       <p:cBhvr>
-                                        <p:cTn id="37" dur="500"/>
+                                        <p:cTn id="59" dur="400"/>
                                         <p:tgtEl>
                                           <p:spTgt spid="21"/>
                                         </p:tgtEl>
@@ -11318,14 +13662,14 @@
                                 </p:cTn>
                               </p:par>
                               <p:par>
-                                <p:cTn id="38" presetID="10" presetClass="entr" presetSubtype="0" fill="hold" nodeType="withEffect">
+                                <p:cTn id="60" presetID="53" presetClass="entr" presetSubtype="16" fill="hold" nodeType="withEffect">
                                   <p:stCondLst>
                                     <p:cond delay="0"/>
                                   </p:stCondLst>
                                   <p:childTnLst>
                                     <p:set>
                                       <p:cBhvr>
-                                        <p:cTn id="39" dur="1" fill="hold">
+                                        <p:cTn id="61" dur="1" fill="hold">
                                           <p:stCondLst>
                                             <p:cond delay="0"/>
                                           </p:stCondLst>
@@ -11341,9 +13685,65 @@
                                         <p:strVal val="visible"/>
                                       </p:to>
                                     </p:set>
+                                    <p:anim calcmode="lin" valueType="num">
+                                      <p:cBhvr>
+                                        <p:cTn id="62" dur="600" fill="hold"/>
+                                        <p:tgtEl>
+                                          <p:spTgt spid="22"/>
+                                        </p:tgtEl>
+                                        <p:attrNameLst>
+                                          <p:attrName>ppt_w</p:attrName>
+                                        </p:attrNameLst>
+                                      </p:cBhvr>
+                                      <p:tavLst>
+                                        <p:tav tm="0">
+                                          <p:val>
+                                            <p:fltVal val="0"/>
+                                          </p:val>
+                                        </p:tav>
+                                        <p:tav tm="65000">
+                                          <p:val>
+                                            <p:strVal val="#ppt_w*1.15"/>
+                                          </p:val>
+                                        </p:tav>
+                                        <p:tav tm="100000">
+                                          <p:val>
+                                            <p:strVal val="#ppt_w"/>
+                                          </p:val>
+                                        </p:tav>
+                                      </p:tavLst>
+                                    </p:anim>
+                                    <p:anim calcmode="lin" valueType="num">
+                                      <p:cBhvr>
+                                        <p:cTn id="63" dur="600" fill="hold"/>
+                                        <p:tgtEl>
+                                          <p:spTgt spid="22"/>
+                                        </p:tgtEl>
+                                        <p:attrNameLst>
+                                          <p:attrName>ppt_h</p:attrName>
+                                        </p:attrNameLst>
+                                      </p:cBhvr>
+                                      <p:tavLst>
+                                        <p:tav tm="0">
+                                          <p:val>
+                                            <p:fltVal val="0"/>
+                                          </p:val>
+                                        </p:tav>
+                                        <p:tav tm="65000">
+                                          <p:val>
+                                            <p:strVal val="#ppt_h*1.15"/>
+                                          </p:val>
+                                        </p:tav>
+                                        <p:tav tm="100000">
+                                          <p:val>
+                                            <p:strVal val="#ppt_h"/>
+                                          </p:val>
+                                        </p:tav>
+                                      </p:tavLst>
+                                    </p:anim>
                                     <p:animEffect transition="in" filter="fade">
                                       <p:cBhvr>
-                                        <p:cTn id="40" dur="500"/>
+                                        <p:cTn id="64" dur="400"/>
                                         <p:tgtEl>
                                           <p:spTgt spid="22"/>
                                         </p:tgtEl>
@@ -11353,14 +13753,14 @@
                                 </p:cTn>
                               </p:par>
                               <p:par>
-                                <p:cTn id="41" presetID="10" presetClass="entr" presetSubtype="0" fill="hold" nodeType="withEffect">
+                                <p:cTn id="65" presetID="53" presetClass="entr" presetSubtype="16" fill="hold" nodeType="withEffect">
                                   <p:stCondLst>
                                     <p:cond delay="0"/>
                                   </p:stCondLst>
                                   <p:childTnLst>
                                     <p:set>
                                       <p:cBhvr>
-                                        <p:cTn id="42" dur="1" fill="hold">
+                                        <p:cTn id="66" dur="1" fill="hold">
                                           <p:stCondLst>
                                             <p:cond delay="0"/>
                                           </p:stCondLst>
@@ -11376,9 +13776,65 @@
                                         <p:strVal val="visible"/>
                                       </p:to>
                                     </p:set>
+                                    <p:anim calcmode="lin" valueType="num">
+                                      <p:cBhvr>
+                                        <p:cTn id="67" dur="600" fill="hold"/>
+                                        <p:tgtEl>
+                                          <p:spTgt spid="23"/>
+                                        </p:tgtEl>
+                                        <p:attrNameLst>
+                                          <p:attrName>ppt_w</p:attrName>
+                                        </p:attrNameLst>
+                                      </p:cBhvr>
+                                      <p:tavLst>
+                                        <p:tav tm="0">
+                                          <p:val>
+                                            <p:fltVal val="0"/>
+                                          </p:val>
+                                        </p:tav>
+                                        <p:tav tm="65000">
+                                          <p:val>
+                                            <p:strVal val="#ppt_w*1.15"/>
+                                          </p:val>
+                                        </p:tav>
+                                        <p:tav tm="100000">
+                                          <p:val>
+                                            <p:strVal val="#ppt_w"/>
+                                          </p:val>
+                                        </p:tav>
+                                      </p:tavLst>
+                                    </p:anim>
+                                    <p:anim calcmode="lin" valueType="num">
+                                      <p:cBhvr>
+                                        <p:cTn id="68" dur="600" fill="hold"/>
+                                        <p:tgtEl>
+                                          <p:spTgt spid="23"/>
+                                        </p:tgtEl>
+                                        <p:attrNameLst>
+                                          <p:attrName>ppt_h</p:attrName>
+                                        </p:attrNameLst>
+                                      </p:cBhvr>
+                                      <p:tavLst>
+                                        <p:tav tm="0">
+                                          <p:val>
+                                            <p:fltVal val="0"/>
+                                          </p:val>
+                                        </p:tav>
+                                        <p:tav tm="65000">
+                                          <p:val>
+                                            <p:strVal val="#ppt_h*1.15"/>
+                                          </p:val>
+                                        </p:tav>
+                                        <p:tav tm="100000">
+                                          <p:val>
+                                            <p:strVal val="#ppt_h"/>
+                                          </p:val>
+                                        </p:tav>
+                                      </p:tavLst>
+                                    </p:anim>
                                     <p:animEffect transition="in" filter="fade">
                                       <p:cBhvr>
-                                        <p:cTn id="43" dur="500"/>
+                                        <p:cTn id="69" dur="400"/>
                                         <p:tgtEl>
                                           <p:spTgt spid="23"/>
                                         </p:tgtEl>
@@ -11388,14 +13844,14 @@
                                 </p:cTn>
                               </p:par>
                               <p:par>
-                                <p:cTn id="44" presetID="10" presetClass="entr" presetSubtype="0" fill="hold" nodeType="withEffect">
+                                <p:cTn id="70" presetID="53" presetClass="entr" presetSubtype="16" fill="hold" nodeType="withEffect">
                                   <p:stCondLst>
                                     <p:cond delay="0"/>
                                   </p:stCondLst>
                                   <p:childTnLst>
                                     <p:set>
                                       <p:cBhvr>
-                                        <p:cTn id="45" dur="1" fill="hold">
+                                        <p:cTn id="71" dur="1" fill="hold">
                                           <p:stCondLst>
                                             <p:cond delay="0"/>
                                           </p:stCondLst>
@@ -11411,9 +13867,65 @@
                                         <p:strVal val="visible"/>
                                       </p:to>
                                     </p:set>
+                                    <p:anim calcmode="lin" valueType="num">
+                                      <p:cBhvr>
+                                        <p:cTn id="72" dur="600" fill="hold"/>
+                                        <p:tgtEl>
+                                          <p:spTgt spid="24"/>
+                                        </p:tgtEl>
+                                        <p:attrNameLst>
+                                          <p:attrName>ppt_w</p:attrName>
+                                        </p:attrNameLst>
+                                      </p:cBhvr>
+                                      <p:tavLst>
+                                        <p:tav tm="0">
+                                          <p:val>
+                                            <p:fltVal val="0"/>
+                                          </p:val>
+                                        </p:tav>
+                                        <p:tav tm="65000">
+                                          <p:val>
+                                            <p:strVal val="#ppt_w*1.15"/>
+                                          </p:val>
+                                        </p:tav>
+                                        <p:tav tm="100000">
+                                          <p:val>
+                                            <p:strVal val="#ppt_w"/>
+                                          </p:val>
+                                        </p:tav>
+                                      </p:tavLst>
+                                    </p:anim>
+                                    <p:anim calcmode="lin" valueType="num">
+                                      <p:cBhvr>
+                                        <p:cTn id="73" dur="600" fill="hold"/>
+                                        <p:tgtEl>
+                                          <p:spTgt spid="24"/>
+                                        </p:tgtEl>
+                                        <p:attrNameLst>
+                                          <p:attrName>ppt_h</p:attrName>
+                                        </p:attrNameLst>
+                                      </p:cBhvr>
+                                      <p:tavLst>
+                                        <p:tav tm="0">
+                                          <p:val>
+                                            <p:fltVal val="0"/>
+                                          </p:val>
+                                        </p:tav>
+                                        <p:tav tm="65000">
+                                          <p:val>
+                                            <p:strVal val="#ppt_h*1.15"/>
+                                          </p:val>
+                                        </p:tav>
+                                        <p:tav tm="100000">
+                                          <p:val>
+                                            <p:strVal val="#ppt_h"/>
+                                          </p:val>
+                                        </p:tav>
+                                      </p:tavLst>
+                                    </p:anim>
                                     <p:animEffect transition="in" filter="fade">
                                       <p:cBhvr>
-                                        <p:cTn id="46" dur="500"/>
+                                        <p:cTn id="74" dur="400"/>
                                         <p:tgtEl>
                                           <p:spTgt spid="24"/>
                                         </p:tgtEl>
@@ -11423,14 +13935,14 @@
                                 </p:cTn>
                               </p:par>
                               <p:par>
-                                <p:cTn id="47" presetID="10" presetClass="entr" presetSubtype="0" fill="hold" nodeType="withEffect">
+                                <p:cTn id="75" presetID="53" presetClass="entr" presetSubtype="16" fill="hold" nodeType="withEffect">
                                   <p:stCondLst>
                                     <p:cond delay="0"/>
                                   </p:stCondLst>
                                   <p:childTnLst>
                                     <p:set>
                                       <p:cBhvr>
-                                        <p:cTn id="48" dur="1" fill="hold">
+                                        <p:cTn id="76" dur="1" fill="hold">
                                           <p:stCondLst>
                                             <p:cond delay="0"/>
                                           </p:stCondLst>
@@ -11446,9 +13958,65 @@
                                         <p:strVal val="visible"/>
                                       </p:to>
                                     </p:set>
+                                    <p:anim calcmode="lin" valueType="num">
+                                      <p:cBhvr>
+                                        <p:cTn id="77" dur="600" fill="hold"/>
+                                        <p:tgtEl>
+                                          <p:spTgt spid="25"/>
+                                        </p:tgtEl>
+                                        <p:attrNameLst>
+                                          <p:attrName>ppt_w</p:attrName>
+                                        </p:attrNameLst>
+                                      </p:cBhvr>
+                                      <p:tavLst>
+                                        <p:tav tm="0">
+                                          <p:val>
+                                            <p:fltVal val="0"/>
+                                          </p:val>
+                                        </p:tav>
+                                        <p:tav tm="65000">
+                                          <p:val>
+                                            <p:strVal val="#ppt_w*1.15"/>
+                                          </p:val>
+                                        </p:tav>
+                                        <p:tav tm="100000">
+                                          <p:val>
+                                            <p:strVal val="#ppt_w"/>
+                                          </p:val>
+                                        </p:tav>
+                                      </p:tavLst>
+                                    </p:anim>
+                                    <p:anim calcmode="lin" valueType="num">
+                                      <p:cBhvr>
+                                        <p:cTn id="78" dur="600" fill="hold"/>
+                                        <p:tgtEl>
+                                          <p:spTgt spid="25"/>
+                                        </p:tgtEl>
+                                        <p:attrNameLst>
+                                          <p:attrName>ppt_h</p:attrName>
+                                        </p:attrNameLst>
+                                      </p:cBhvr>
+                                      <p:tavLst>
+                                        <p:tav tm="0">
+                                          <p:val>
+                                            <p:fltVal val="0"/>
+                                          </p:val>
+                                        </p:tav>
+                                        <p:tav tm="65000">
+                                          <p:val>
+                                            <p:strVal val="#ppt_h*1.15"/>
+                                          </p:val>
+                                        </p:tav>
+                                        <p:tav tm="100000">
+                                          <p:val>
+                                            <p:strVal val="#ppt_h"/>
+                                          </p:val>
+                                        </p:tav>
+                                      </p:tavLst>
+                                    </p:anim>
                                     <p:animEffect transition="in" filter="fade">
                                       <p:cBhvr>
-                                        <p:cTn id="49" dur="500"/>
+                                        <p:cTn id="79" dur="400"/>
                                         <p:tgtEl>
                                           <p:spTgt spid="25"/>
                                         </p:tgtEl>
@@ -11458,14 +14026,14 @@
                                 </p:cTn>
                               </p:par>
                               <p:par>
-                                <p:cTn id="50" presetID="10" presetClass="entr" presetSubtype="0" fill="hold" nodeType="withEffect">
+                                <p:cTn id="80" presetID="53" presetClass="entr" presetSubtype="16" fill="hold" nodeType="withEffect">
                                   <p:stCondLst>
                                     <p:cond delay="0"/>
                                   </p:stCondLst>
                                   <p:childTnLst>
                                     <p:set>
                                       <p:cBhvr>
-                                        <p:cTn id="51" dur="1" fill="hold">
+                                        <p:cTn id="81" dur="1" fill="hold">
                                           <p:stCondLst>
                                             <p:cond delay="0"/>
                                           </p:stCondLst>
@@ -11481,9 +14049,65 @@
                                         <p:strVal val="visible"/>
                                       </p:to>
                                     </p:set>
+                                    <p:anim calcmode="lin" valueType="num">
+                                      <p:cBhvr>
+                                        <p:cTn id="82" dur="600" fill="hold"/>
+                                        <p:tgtEl>
+                                          <p:spTgt spid="26"/>
+                                        </p:tgtEl>
+                                        <p:attrNameLst>
+                                          <p:attrName>ppt_w</p:attrName>
+                                        </p:attrNameLst>
+                                      </p:cBhvr>
+                                      <p:tavLst>
+                                        <p:tav tm="0">
+                                          <p:val>
+                                            <p:fltVal val="0"/>
+                                          </p:val>
+                                        </p:tav>
+                                        <p:tav tm="65000">
+                                          <p:val>
+                                            <p:strVal val="#ppt_w*1.15"/>
+                                          </p:val>
+                                        </p:tav>
+                                        <p:tav tm="100000">
+                                          <p:val>
+                                            <p:strVal val="#ppt_w"/>
+                                          </p:val>
+                                        </p:tav>
+                                      </p:tavLst>
+                                    </p:anim>
+                                    <p:anim calcmode="lin" valueType="num">
+                                      <p:cBhvr>
+                                        <p:cTn id="83" dur="600" fill="hold"/>
+                                        <p:tgtEl>
+                                          <p:spTgt spid="26"/>
+                                        </p:tgtEl>
+                                        <p:attrNameLst>
+                                          <p:attrName>ppt_h</p:attrName>
+                                        </p:attrNameLst>
+                                      </p:cBhvr>
+                                      <p:tavLst>
+                                        <p:tav tm="0">
+                                          <p:val>
+                                            <p:fltVal val="0"/>
+                                          </p:val>
+                                        </p:tav>
+                                        <p:tav tm="65000">
+                                          <p:val>
+                                            <p:strVal val="#ppt_h*1.15"/>
+                                          </p:val>
+                                        </p:tav>
+                                        <p:tav tm="100000">
+                                          <p:val>
+                                            <p:strVal val="#ppt_h"/>
+                                          </p:val>
+                                        </p:tav>
+                                      </p:tavLst>
+                                    </p:anim>
                                     <p:animEffect transition="in" filter="fade">
                                       <p:cBhvr>
-                                        <p:cTn id="52" dur="500"/>
+                                        <p:cTn id="84" dur="400"/>
                                         <p:tgtEl>
                                           <p:spTgt spid="26"/>
                                         </p:tgtEl>
@@ -11528,40 +14152,40 @@
   <a:themeElements>
     <a:clrScheme name="Food Chains Review">
       <a:dk1>
-        <a:srgbClr val="1E3320"/>
+        <a:srgbClr val="2D3A30"/>
       </a:dk1>
       <a:lt1>
         <a:srgbClr val="FFFFFF"/>
       </a:lt1>
       <a:dk2>
-        <a:srgbClr val="245B2A"/>
+        <a:srgbClr val="2E7D32"/>
       </a:dk2>
       <a:lt2>
-        <a:srgbClr val="EEF6E8"/>
+        <a:srgbClr val="F1FAEC"/>
       </a:lt2>
       <a:accent1>
-        <a:srgbClr val="4E9A2F"/>
+        <a:srgbClr val="5DB85C"/>
       </a:accent1>
       <a:accent2>
-        <a:srgbClr val="D7262E"/>
+        <a:srgbClr val="E8505B"/>
       </a:accent2>
       <a:accent3>
-        <a:srgbClr val="F6D93B"/>
+        <a:srgbClr val="FCE38A"/>
       </a:accent3>
       <a:accent4>
-        <a:srgbClr val="E98A2C"/>
+        <a:srgbClr val="F7A04B"/>
       </a:accent4>
       <a:accent5>
-        <a:srgbClr val="2A6FB0"/>
+        <a:srgbClr val="4AA8E0"/>
       </a:accent5>
       <a:accent6>
-        <a:srgbClr val="7A4FA0"/>
+        <a:srgbClr val="D6F1C9"/>
       </a:accent6>
       <a:hlink>
-        <a:srgbClr val="2A6FB0"/>
+        <a:srgbClr val="4AA8E0"/>
       </a:hlink>
       <a:folHlink>
-        <a:srgbClr val="7A4FA0"/>
+        <a:srgbClr val="B48DE0"/>
       </a:folHlink>
     </a:clrScheme>
     <a:fontScheme name="Food Chains Review">

</xml_diff>